<commit_message>
Presentation: manual edits to the deck (wording on slides 3, 5 and 7)
Co-Authored-By: Claude Fable 5.1 <noreply@anthropic.com>
</commit_message>
<xml_diff>
--- a/docs/presentation.pptx
+++ b/docs/presentation.pptx
@@ -4,17 +4,20 @@
   <p:sldMasterIdLst>
     <p:sldMasterId id="2147483648" r:id="rId1"/>
   </p:sldMasterIdLst>
+  <p:notesMasterIdLst>
+    <p:notesMasterId r:id="rId10"/>
+  </p:notesMasterIdLst>
   <p:sldIdLst>
-    <p:sldId id="256" r:id="rId7"/>
-    <p:sldId id="257" r:id="rId9"/>
-    <p:sldId id="258" r:id="rId10"/>
-    <p:sldId id="259" r:id="rId11"/>
-    <p:sldId id="260" r:id="rId12"/>
-    <p:sldId id="261" r:id="rId13"/>
-    <p:sldId id="262" r:id="rId14"/>
-    <p:sldId id="263" r:id="rId15"/>
+    <p:sldId id="256" r:id="rId2"/>
+    <p:sldId id="257" r:id="rId3"/>
+    <p:sldId id="258" r:id="rId4"/>
+    <p:sldId id="259" r:id="rId5"/>
+    <p:sldId id="260" r:id="rId6"/>
+    <p:sldId id="261" r:id="rId7"/>
+    <p:sldId id="262" r:id="rId8"/>
+    <p:sldId id="263" r:id="rId9"/>
   </p:sldIdLst>
-  <p:sldSz cx="12191695" cy="6858000" type="screen4x3"/>
+  <p:sldSz cx="12192000" cy="6858000"/>
   <p:notesSz cx="6858000" cy="9144000"/>
   <p:defaultTextStyle>
     <a:defPPr>
@@ -111,11 +114,27 @@
       </a:defRPr>
     </a:lvl9pPr>
   </p:defaultTextStyle>
+  <p:extLst>
+    <p:ext uri="{EFAFB233-063F-42B5-8137-9DF3F51BA10A}">
+      <p15:sldGuideLst xmlns:p15="http://schemas.microsoft.com/office/powerpoint/2012/main">
+        <p15:guide id="1" orient="horz" pos="2160">
+          <p15:clr>
+            <a:srgbClr val="A4A3A4"/>
+          </p15:clr>
+        </p15:guide>
+        <p15:guide id="2" pos="2880">
+          <p15:clr>
+            <a:srgbClr val="A4A3A4"/>
+          </p15:clr>
+        </p15:guide>
+      </p15:sldGuideLst>
+    </p:ext>
+  </p:extLst>
 </p:presentation>
 </file>
 
 <file path=ppt/notesMasters/notesMaster1.xml><?xml version="1.0" encoding="utf-8"?>
-<p:notesMaster xmlns:a="http://schemas.openxmlformats.org/drawingml/2006/main" xmlns:p="http://schemas.openxmlformats.org/presentationml/2006/main" xmlns:r="http://schemas.openxmlformats.org/officeDocument/2006/relationships">
+<p:notesMaster xmlns:a="http://schemas.openxmlformats.org/drawingml/2006/main" xmlns:r="http://schemas.openxmlformats.org/officeDocument/2006/relationships" xmlns:p="http://schemas.openxmlformats.org/presentationml/2006/main">
   <p:cSld>
     <p:bg>
       <p:bgRef idx="1001">
@@ -136,241 +155,16 @@
           <a:chExt cx="0" cy="0"/>
         </a:xfrm>
       </p:grpSpPr>
-      <p:sp>
-        <p:nvSpPr>
-          <p:cNvPr id="2" name="Header Placeholder 1"/>
-          <p:cNvSpPr>
-            <a:spLocks noGrp="1"/>
-          </p:cNvSpPr>
-          <p:nvPr>
-            <p:ph type="hdr" sz="quarter"/>
-          </p:nvPr>
-        </p:nvSpPr>
-        <p:spPr>
-          <a:xfrm>
-            <a:off x="0" y="0"/>
-            <a:ext cx="2971800" cy="457200"/>
-          </a:xfrm>
-          <a:prstGeom prst="rect">
-            <a:avLst/>
-          </a:prstGeom>
-        </p:spPr>
-        <p:txBody>
-          <a:bodyPr vert="horz" lIns="91440" tIns="45720" rIns="91440" bIns="45720" rtlCol="0"/>
-          <a:lstStyle>
-            <a:lvl1pPr algn="l">
-              <a:defRPr sz="1200"/>
-            </a:lvl1pPr>
-          </a:lstStyle>
-          <a:p>
-            <a:endParaRPr lang="en-US"/>
-          </a:p>
-        </p:txBody>
-      </p:sp>
-      <p:sp>
-        <p:nvSpPr>
-          <p:cNvPr id="3" name="Date Placeholder 2"/>
-          <p:cNvSpPr>
-            <a:spLocks noGrp="1"/>
-          </p:cNvSpPr>
-          <p:nvPr>
-            <p:ph type="dt" idx="1"/>
-          </p:nvPr>
-        </p:nvSpPr>
-        <p:spPr>
-          <a:xfrm>
-            <a:off x="3884613" y="0"/>
-            <a:ext cx="2971800" cy="457200"/>
-          </a:xfrm>
-          <a:prstGeom prst="rect">
-            <a:avLst/>
-          </a:prstGeom>
-        </p:spPr>
-        <p:txBody>
-          <a:bodyPr vert="horz" lIns="91440" tIns="45720" rIns="91440" bIns="45720" rtlCol="0"/>
-          <a:lstStyle>
-            <a:lvl1pPr algn="r">
-              <a:defRPr sz="1200"/>
-            </a:lvl1pPr>
-          </a:lstStyle>
-          <a:p>
-            <a:fld id="{0F89C1C7-3DCD-1040-A9CF-14679D8B5DDD}" type="datetimeFigureOut">
-              <a:rPr lang="en-US" smtClean="0"/>
-              <a:t>10/17/16</a:t>
-            </a:fld>
-            <a:endParaRPr lang="en-US"/>
-          </a:p>
-        </p:txBody>
-      </p:sp>
-      <p:sp>
-        <p:nvSpPr>
-          <p:cNvPr id="4" name="Slide Image Placeholder 3"/>
-          <p:cNvSpPr>
-            <a:spLocks noGrp="1" noRot="1" noChangeAspect="1"/>
-          </p:cNvSpPr>
-          <p:nvPr>
-            <p:ph type="sldImg" idx="2"/>
-          </p:nvPr>
-        </p:nvSpPr>
-        <p:spPr>
-          <a:xfrm>
-            <a:off x="1143000" y="685800"/>
-            <a:ext cx="4572000" cy="3429000"/>
-          </a:xfrm>
-          <a:prstGeom prst="rect">
-            <a:avLst/>
-          </a:prstGeom>
-          <a:noFill/>
-          <a:ln w="12700">
-            <a:solidFill>
-              <a:prstClr val="black"/>
-            </a:solidFill>
-          </a:ln>
-        </p:spPr>
-        <p:txBody>
-          <a:bodyPr vert="horz" lIns="91440" tIns="45720" rIns="91440" bIns="45720" rtlCol="0" anchor="ctr"/>
-          <a:lstStyle/>
-          <a:p>
-            <a:endParaRPr lang="en-US"/>
-          </a:p>
-        </p:txBody>
-      </p:sp>
-      <p:sp>
-        <p:nvSpPr>
-          <p:cNvPr id="5" name="Notes Placeholder 4"/>
-          <p:cNvSpPr>
-            <a:spLocks noGrp="1"/>
-          </p:cNvSpPr>
-          <p:nvPr>
-            <p:ph type="body" sz="quarter" idx="3"/>
-          </p:nvPr>
-        </p:nvSpPr>
-        <p:spPr>
-          <a:xfrm>
-            <a:off x="685800" y="4343400"/>
-            <a:ext cx="5486400" cy="4114800"/>
-          </a:xfrm>
-          <a:prstGeom prst="rect">
-            <a:avLst/>
-          </a:prstGeom>
-        </p:spPr>
-        <p:txBody>
-          <a:bodyPr vert="horz" lIns="91440" tIns="45720" rIns="91440" bIns="45720" rtlCol="0"/>
-          <a:lstStyle/>
-          <a:p>
-            <a:pPr lvl="0"/>
-            <a:r>
-              <a:rPr lang="en-US" smtClean="0"/>
-              <a:t>Click to edit Master text styles</a:t>
-            </a:r>
-          </a:p>
-          <a:p>
-            <a:pPr lvl="1"/>
-            <a:r>
-              <a:rPr lang="en-US" smtClean="0"/>
-              <a:t>Second level</a:t>
-            </a:r>
-          </a:p>
-          <a:p>
-            <a:pPr lvl="2"/>
-            <a:r>
-              <a:rPr lang="en-US" smtClean="0"/>
-              <a:t>Third level</a:t>
-            </a:r>
-          </a:p>
-          <a:p>
-            <a:pPr lvl="3"/>
-            <a:r>
-              <a:rPr lang="en-US" smtClean="0"/>
-              <a:t>Fourth level</a:t>
-            </a:r>
-          </a:p>
-          <a:p>
-            <a:pPr lvl="4"/>
-            <a:r>
-              <a:rPr lang="en-US" smtClean="0"/>
-              <a:t>Fifth level</a:t>
-            </a:r>
-            <a:endParaRPr lang="en-US"/>
-          </a:p>
-        </p:txBody>
-      </p:sp>
-      <p:sp>
-        <p:nvSpPr>
-          <p:cNvPr id="6" name="Footer Placeholder 5"/>
-          <p:cNvSpPr>
-            <a:spLocks noGrp="1"/>
-          </p:cNvSpPr>
-          <p:nvPr>
-            <p:ph type="ftr" sz="quarter" idx="4"/>
-          </p:nvPr>
-        </p:nvSpPr>
-        <p:spPr>
-          <a:xfrm>
-            <a:off x="0" y="8685213"/>
-            <a:ext cx="2971800" cy="457200"/>
-          </a:xfrm>
-          <a:prstGeom prst="rect">
-            <a:avLst/>
-          </a:prstGeom>
-        </p:spPr>
-        <p:txBody>
-          <a:bodyPr vert="horz" lIns="91440" tIns="45720" rIns="91440" bIns="45720" rtlCol="0" anchor="b"/>
-          <a:lstStyle>
-            <a:lvl1pPr algn="l">
-              <a:defRPr sz="1200"/>
-            </a:lvl1pPr>
-          </a:lstStyle>
-          <a:p>
-            <a:endParaRPr lang="en-US"/>
-          </a:p>
-        </p:txBody>
-      </p:sp>
-      <p:sp>
-        <p:nvSpPr>
-          <p:cNvPr id="7" name="Slide Number Placeholder 6"/>
-          <p:cNvSpPr>
-            <a:spLocks noGrp="1"/>
-          </p:cNvSpPr>
-          <p:nvPr>
-            <p:ph type="sldNum" sz="quarter" idx="5"/>
-          </p:nvPr>
-        </p:nvSpPr>
-        <p:spPr>
-          <a:xfrm>
-            <a:off x="3884613" y="8685213"/>
-            <a:ext cx="2971800" cy="457200"/>
-          </a:xfrm>
-          <a:prstGeom prst="rect">
-            <a:avLst/>
-          </a:prstGeom>
-        </p:spPr>
-        <p:txBody>
-          <a:bodyPr vert="horz" lIns="91440" tIns="45720" rIns="91440" bIns="45720" rtlCol="0" anchor="b"/>
-          <a:lstStyle>
-            <a:lvl1pPr algn="r">
-              <a:defRPr sz="1200"/>
-            </a:lvl1pPr>
-          </a:lstStyle>
-          <a:p>
-            <a:fld id="{BB5E49A5-4136-284D-997B-48E1D791AD67}" type="slidenum">
-              <a:rPr lang="en-US" smtClean="0"/>
-              <a:t>‹#›</a:t>
-            </a:fld>
-            <a:endParaRPr lang="en-US"/>
-          </a:p>
-        </p:txBody>
-      </p:sp>
     </p:spTree>
     <p:extLst>
       <p:ext uri="{BB962C8B-B14F-4D97-AF65-F5344CB8AC3E}">
-        <p14:creationId xmlns:p14="http://schemas.microsoft.com/office/powerpoint/2010/main" val="2623252185"/>
+        <p14:creationId xmlns:p14="http://schemas.microsoft.com/office/powerpoint/2010/main" val="1934159321"/>
       </p:ext>
     </p:extLst>
   </p:cSld>
   <p:clrMap bg1="lt1" tx1="dk1" bg2="lt2" tx2="dk2" accent1="accent1" accent2="accent2" accent3="accent3" accent4="accent4" accent5="accent5" accent6="accent6" hlink="hlink" folHlink="folHlink"/>
   <p:notesStyle>
-    <a:lvl1pPr marL="0" algn="l" defTabSz="457200" rtl="0" eaLnBrk="1" latinLnBrk="0" hangingPunct="1">
+    <a:lvl1pPr marL="0" algn="l" defTabSz="914400" rtl="0" eaLnBrk="1" latinLnBrk="0" hangingPunct="1">
       <a:defRPr sz="1200" kern="1200">
         <a:solidFill>
           <a:schemeClr val="tx1"/>
@@ -380,7 +174,7 @@
         <a:cs typeface="+mn-cs"/>
       </a:defRPr>
     </a:lvl1pPr>
-    <a:lvl2pPr marL="457200" algn="l" defTabSz="457200" rtl="0" eaLnBrk="1" latinLnBrk="0" hangingPunct="1">
+    <a:lvl2pPr marL="457200" algn="l" defTabSz="914400" rtl="0" eaLnBrk="1" latinLnBrk="0" hangingPunct="1">
       <a:defRPr sz="1200" kern="1200">
         <a:solidFill>
           <a:schemeClr val="tx1"/>
@@ -390,7 +184,7 @@
         <a:cs typeface="+mn-cs"/>
       </a:defRPr>
     </a:lvl2pPr>
-    <a:lvl3pPr marL="914400" algn="l" defTabSz="457200" rtl="0" eaLnBrk="1" latinLnBrk="0" hangingPunct="1">
+    <a:lvl3pPr marL="914400" algn="l" defTabSz="914400" rtl="0" eaLnBrk="1" latinLnBrk="0" hangingPunct="1">
       <a:defRPr sz="1200" kern="1200">
         <a:solidFill>
           <a:schemeClr val="tx1"/>
@@ -400,7 +194,7 @@
         <a:cs typeface="+mn-cs"/>
       </a:defRPr>
     </a:lvl3pPr>
-    <a:lvl4pPr marL="1371600" algn="l" defTabSz="457200" rtl="0" eaLnBrk="1" latinLnBrk="0" hangingPunct="1">
+    <a:lvl4pPr marL="1371600" algn="l" defTabSz="914400" rtl="0" eaLnBrk="1" latinLnBrk="0" hangingPunct="1">
       <a:defRPr sz="1200" kern="1200">
         <a:solidFill>
           <a:schemeClr val="tx1"/>
@@ -410,7 +204,7 @@
         <a:cs typeface="+mn-cs"/>
       </a:defRPr>
     </a:lvl4pPr>
-    <a:lvl5pPr marL="1828800" algn="l" defTabSz="457200" rtl="0" eaLnBrk="1" latinLnBrk="0" hangingPunct="1">
+    <a:lvl5pPr marL="1828800" algn="l" defTabSz="914400" rtl="0" eaLnBrk="1" latinLnBrk="0" hangingPunct="1">
       <a:defRPr sz="1200" kern="1200">
         <a:solidFill>
           <a:schemeClr val="tx1"/>
@@ -420,7 +214,7 @@
         <a:cs typeface="+mn-cs"/>
       </a:defRPr>
     </a:lvl5pPr>
-    <a:lvl6pPr marL="2286000" algn="l" defTabSz="457200" rtl="0" eaLnBrk="1" latinLnBrk="0" hangingPunct="1">
+    <a:lvl6pPr marL="2286000" algn="l" defTabSz="914400" rtl="0" eaLnBrk="1" latinLnBrk="0" hangingPunct="1">
       <a:defRPr sz="1200" kern="1200">
         <a:solidFill>
           <a:schemeClr val="tx1"/>
@@ -430,7 +224,7 @@
         <a:cs typeface="+mn-cs"/>
       </a:defRPr>
     </a:lvl6pPr>
-    <a:lvl7pPr marL="2743200" algn="l" defTabSz="457200" rtl="0" eaLnBrk="1" latinLnBrk="0" hangingPunct="1">
+    <a:lvl7pPr marL="2743200" algn="l" defTabSz="914400" rtl="0" eaLnBrk="1" latinLnBrk="0" hangingPunct="1">
       <a:defRPr sz="1200" kern="1200">
         <a:solidFill>
           <a:schemeClr val="tx1"/>
@@ -440,7 +234,7 @@
         <a:cs typeface="+mn-cs"/>
       </a:defRPr>
     </a:lvl7pPr>
-    <a:lvl8pPr marL="3200400" algn="l" defTabSz="457200" rtl="0" eaLnBrk="1" latinLnBrk="0" hangingPunct="1">
+    <a:lvl8pPr marL="3200400" algn="l" defTabSz="914400" rtl="0" eaLnBrk="1" latinLnBrk="0" hangingPunct="1">
       <a:defRPr sz="1200" kern="1200">
         <a:solidFill>
           <a:schemeClr val="tx1"/>
@@ -450,7 +244,7 @@
         <a:cs typeface="+mn-cs"/>
       </a:defRPr>
     </a:lvl8pPr>
-    <a:lvl9pPr marL="3657600" algn="l" defTabSz="457200" rtl="0" eaLnBrk="1" latinLnBrk="0" hangingPunct="1">
+    <a:lvl9pPr marL="3657600" algn="l" defTabSz="914400" rtl="0" eaLnBrk="1" latinLnBrk="0" hangingPunct="1">
       <a:defRPr sz="1200" kern="1200">
         <a:solidFill>
           <a:schemeClr val="tx1"/>
@@ -465,7 +259,7 @@
 </file>
 
 <file path=ppt/notesSlides/notesSlide1.xml><?xml version="1.0" encoding="utf-8"?>
-<p:notes xmlns:a="http://schemas.openxmlformats.org/drawingml/2006/main" xmlns:p="http://schemas.openxmlformats.org/presentationml/2006/main" xmlns:r="http://schemas.openxmlformats.org/officeDocument/2006/relationships">
+<p:notes xmlns:a="http://schemas.openxmlformats.org/drawingml/2006/main" xmlns:r="http://schemas.openxmlformats.org/officeDocument/2006/relationships" xmlns:p="http://schemas.openxmlformats.org/presentationml/2006/main">
   <p:cSld>
     <p:spTree>
       <p:nvGrpSpPr>
@@ -485,7 +279,7 @@
         <p:nvSpPr>
           <p:cNvPr id="2" name="Slide Image Placeholder 1"/>
           <p:cNvSpPr>
-            <a:spLocks noGrp="1"/>
+            <a:spLocks noGrp="1" noRot="1" noChangeAspect="1"/>
           </p:cNvSpPr>
           <p:nvPr>
             <p:ph type="sldImg" idx="2"/>
@@ -500,7 +294,7 @@
             <a:spLocks noGrp="1"/>
           </p:cNvSpPr>
           <p:nvPr>
-            <p:ph type="body" idx="3" sz="quarter"/>
+            <p:ph type="body" sz="quarter" idx="3"/>
           </p:nvPr>
         </p:nvSpPr>
         <p:spPr/>
@@ -521,7 +315,7 @@
             <a:spLocks noGrp="1"/>
           </p:cNvSpPr>
           <p:nvPr>
-            <p:ph type="sldNum" idx="5" sz="quarter"/>
+            <p:ph type="sldNum" sz="quarter" idx="5"/>
           </p:nvPr>
         </p:nvSpPr>
         <p:spPr/>
@@ -535,7 +329,7 @@
 </file>
 
 <file path=ppt/notesSlides/notesSlide2.xml><?xml version="1.0" encoding="utf-8"?>
-<p:notes xmlns:a="http://schemas.openxmlformats.org/drawingml/2006/main" xmlns:p="http://schemas.openxmlformats.org/presentationml/2006/main" xmlns:r="http://schemas.openxmlformats.org/officeDocument/2006/relationships">
+<p:notes xmlns:a="http://schemas.openxmlformats.org/drawingml/2006/main" xmlns:r="http://schemas.openxmlformats.org/officeDocument/2006/relationships" xmlns:p="http://schemas.openxmlformats.org/presentationml/2006/main">
   <p:cSld>
     <p:spTree>
       <p:nvGrpSpPr>
@@ -555,7 +349,7 @@
         <p:nvSpPr>
           <p:cNvPr id="2" name="Slide Image Placeholder 1"/>
           <p:cNvSpPr>
-            <a:spLocks noGrp="1"/>
+            <a:spLocks noGrp="1" noRot="1" noChangeAspect="1"/>
           </p:cNvSpPr>
           <p:nvPr>
             <p:ph type="sldImg" idx="2"/>
@@ -570,7 +364,7 @@
             <a:spLocks noGrp="1"/>
           </p:cNvSpPr>
           <p:nvPr>
-            <p:ph type="body" idx="3" sz="quarter"/>
+            <p:ph type="body" sz="quarter" idx="3"/>
           </p:nvPr>
         </p:nvSpPr>
         <p:spPr/>
@@ -591,7 +385,7 @@
             <a:spLocks noGrp="1"/>
           </p:cNvSpPr>
           <p:nvPr>
-            <p:ph type="sldNum" idx="5" sz="quarter"/>
+            <p:ph type="sldNum" sz="quarter" idx="5"/>
           </p:nvPr>
         </p:nvSpPr>
         <p:spPr/>
@@ -605,7 +399,7 @@
 </file>
 
 <file path=ppt/notesSlides/notesSlide3.xml><?xml version="1.0" encoding="utf-8"?>
-<p:notes xmlns:a="http://schemas.openxmlformats.org/drawingml/2006/main" xmlns:p="http://schemas.openxmlformats.org/presentationml/2006/main" xmlns:r="http://schemas.openxmlformats.org/officeDocument/2006/relationships">
+<p:notes xmlns:a="http://schemas.openxmlformats.org/drawingml/2006/main" xmlns:r="http://schemas.openxmlformats.org/officeDocument/2006/relationships" xmlns:p="http://schemas.openxmlformats.org/presentationml/2006/main">
   <p:cSld>
     <p:spTree>
       <p:nvGrpSpPr>
@@ -625,7 +419,7 @@
         <p:nvSpPr>
           <p:cNvPr id="2" name="Slide Image Placeholder 1"/>
           <p:cNvSpPr>
-            <a:spLocks noGrp="1"/>
+            <a:spLocks noGrp="1" noRot="1" noChangeAspect="1"/>
           </p:cNvSpPr>
           <p:nvPr>
             <p:ph type="sldImg" idx="2"/>
@@ -640,7 +434,7 @@
             <a:spLocks noGrp="1"/>
           </p:cNvSpPr>
           <p:nvPr>
-            <p:ph type="body" idx="3" sz="quarter"/>
+            <p:ph type="body" sz="quarter" idx="3"/>
           </p:nvPr>
         </p:nvSpPr>
         <p:spPr/>
@@ -661,7 +455,7 @@
             <a:spLocks noGrp="1"/>
           </p:cNvSpPr>
           <p:nvPr>
-            <p:ph type="sldNum" idx="5" sz="quarter"/>
+            <p:ph type="sldNum" sz="quarter" idx="5"/>
           </p:nvPr>
         </p:nvSpPr>
         <p:spPr/>
@@ -675,7 +469,7 @@
 </file>
 
 <file path=ppt/notesSlides/notesSlide4.xml><?xml version="1.0" encoding="utf-8"?>
-<p:notes xmlns:a="http://schemas.openxmlformats.org/drawingml/2006/main" xmlns:p="http://schemas.openxmlformats.org/presentationml/2006/main" xmlns:r="http://schemas.openxmlformats.org/officeDocument/2006/relationships">
+<p:notes xmlns:a="http://schemas.openxmlformats.org/drawingml/2006/main" xmlns:r="http://schemas.openxmlformats.org/officeDocument/2006/relationships" xmlns:p="http://schemas.openxmlformats.org/presentationml/2006/main">
   <p:cSld>
     <p:spTree>
       <p:nvGrpSpPr>
@@ -695,7 +489,7 @@
         <p:nvSpPr>
           <p:cNvPr id="2" name="Slide Image Placeholder 1"/>
           <p:cNvSpPr>
-            <a:spLocks noGrp="1"/>
+            <a:spLocks noGrp="1" noRot="1" noChangeAspect="1"/>
           </p:cNvSpPr>
           <p:nvPr>
             <p:ph type="sldImg" idx="2"/>
@@ -710,7 +504,7 @@
             <a:spLocks noGrp="1"/>
           </p:cNvSpPr>
           <p:nvPr>
-            <p:ph type="body" idx="3" sz="quarter"/>
+            <p:ph type="body" sz="quarter" idx="3"/>
           </p:nvPr>
         </p:nvSpPr>
         <p:spPr/>
@@ -731,7 +525,7 @@
             <a:spLocks noGrp="1"/>
           </p:cNvSpPr>
           <p:nvPr>
-            <p:ph type="sldNum" idx="5" sz="quarter"/>
+            <p:ph type="sldNum" sz="quarter" idx="5"/>
           </p:nvPr>
         </p:nvSpPr>
         <p:spPr/>
@@ -745,7 +539,7 @@
 </file>
 
 <file path=ppt/notesSlides/notesSlide5.xml><?xml version="1.0" encoding="utf-8"?>
-<p:notes xmlns:a="http://schemas.openxmlformats.org/drawingml/2006/main" xmlns:p="http://schemas.openxmlformats.org/presentationml/2006/main" xmlns:r="http://schemas.openxmlformats.org/officeDocument/2006/relationships">
+<p:notes xmlns:a="http://schemas.openxmlformats.org/drawingml/2006/main" xmlns:r="http://schemas.openxmlformats.org/officeDocument/2006/relationships" xmlns:p="http://schemas.openxmlformats.org/presentationml/2006/main">
   <p:cSld>
     <p:spTree>
       <p:nvGrpSpPr>
@@ -765,7 +559,7 @@
         <p:nvSpPr>
           <p:cNvPr id="2" name="Slide Image Placeholder 1"/>
           <p:cNvSpPr>
-            <a:spLocks noGrp="1"/>
+            <a:spLocks noGrp="1" noRot="1" noChangeAspect="1"/>
           </p:cNvSpPr>
           <p:nvPr>
             <p:ph type="sldImg" idx="2"/>
@@ -780,7 +574,7 @@
             <a:spLocks noGrp="1"/>
           </p:cNvSpPr>
           <p:nvPr>
-            <p:ph type="body" idx="3" sz="quarter"/>
+            <p:ph type="body" sz="quarter" idx="3"/>
           </p:nvPr>
         </p:nvSpPr>
         <p:spPr/>
@@ -801,7 +595,7 @@
             <a:spLocks noGrp="1"/>
           </p:cNvSpPr>
           <p:nvPr>
-            <p:ph type="sldNum" idx="5" sz="quarter"/>
+            <p:ph type="sldNum" sz="quarter" idx="5"/>
           </p:nvPr>
         </p:nvSpPr>
         <p:spPr/>
@@ -815,7 +609,7 @@
 </file>
 
 <file path=ppt/notesSlides/notesSlide6.xml><?xml version="1.0" encoding="utf-8"?>
-<p:notes xmlns:a="http://schemas.openxmlformats.org/drawingml/2006/main" xmlns:p="http://schemas.openxmlformats.org/presentationml/2006/main" xmlns:r="http://schemas.openxmlformats.org/officeDocument/2006/relationships">
+<p:notes xmlns:a="http://schemas.openxmlformats.org/drawingml/2006/main" xmlns:r="http://schemas.openxmlformats.org/officeDocument/2006/relationships" xmlns:p="http://schemas.openxmlformats.org/presentationml/2006/main">
   <p:cSld>
     <p:spTree>
       <p:nvGrpSpPr>
@@ -835,7 +629,7 @@
         <p:nvSpPr>
           <p:cNvPr id="2" name="Slide Image Placeholder 1"/>
           <p:cNvSpPr>
-            <a:spLocks noGrp="1"/>
+            <a:spLocks noGrp="1" noRot="1" noChangeAspect="1"/>
           </p:cNvSpPr>
           <p:nvPr>
             <p:ph type="sldImg" idx="2"/>
@@ -850,7 +644,7 @@
             <a:spLocks noGrp="1"/>
           </p:cNvSpPr>
           <p:nvPr>
-            <p:ph type="body" idx="3" sz="quarter"/>
+            <p:ph type="body" sz="quarter" idx="3"/>
           </p:nvPr>
         </p:nvSpPr>
         <p:spPr/>
@@ -871,7 +665,7 @@
             <a:spLocks noGrp="1"/>
           </p:cNvSpPr>
           <p:nvPr>
-            <p:ph type="sldNum" idx="5" sz="quarter"/>
+            <p:ph type="sldNum" sz="quarter" idx="5"/>
           </p:nvPr>
         </p:nvSpPr>
         <p:spPr/>
@@ -885,7 +679,7 @@
 </file>
 
 <file path=ppt/notesSlides/notesSlide7.xml><?xml version="1.0" encoding="utf-8"?>
-<p:notes xmlns:a="http://schemas.openxmlformats.org/drawingml/2006/main" xmlns:p="http://schemas.openxmlformats.org/presentationml/2006/main" xmlns:r="http://schemas.openxmlformats.org/officeDocument/2006/relationships">
+<p:notes xmlns:a="http://schemas.openxmlformats.org/drawingml/2006/main" xmlns:r="http://schemas.openxmlformats.org/officeDocument/2006/relationships" xmlns:p="http://schemas.openxmlformats.org/presentationml/2006/main">
   <p:cSld>
     <p:spTree>
       <p:nvGrpSpPr>
@@ -905,7 +699,7 @@
         <p:nvSpPr>
           <p:cNvPr id="2" name="Slide Image Placeholder 1"/>
           <p:cNvSpPr>
-            <a:spLocks noGrp="1"/>
+            <a:spLocks noGrp="1" noRot="1" noChangeAspect="1"/>
           </p:cNvSpPr>
           <p:nvPr>
             <p:ph type="sldImg" idx="2"/>
@@ -920,7 +714,7 @@
             <a:spLocks noGrp="1"/>
           </p:cNvSpPr>
           <p:nvPr>
-            <p:ph type="body" idx="3" sz="quarter"/>
+            <p:ph type="body" sz="quarter" idx="3"/>
           </p:nvPr>
         </p:nvSpPr>
         <p:spPr/>
@@ -941,7 +735,7 @@
             <a:spLocks noGrp="1"/>
           </p:cNvSpPr>
           <p:nvPr>
-            <p:ph type="sldNum" idx="5" sz="quarter"/>
+            <p:ph type="sldNum" sz="quarter" idx="5"/>
           </p:nvPr>
         </p:nvSpPr>
         <p:spPr/>
@@ -955,7 +749,7 @@
 </file>
 
 <file path=ppt/notesSlides/notesSlide8.xml><?xml version="1.0" encoding="utf-8"?>
-<p:notes xmlns:a="http://schemas.openxmlformats.org/drawingml/2006/main" xmlns:p="http://schemas.openxmlformats.org/presentationml/2006/main" xmlns:r="http://schemas.openxmlformats.org/officeDocument/2006/relationships">
+<p:notes xmlns:a="http://schemas.openxmlformats.org/drawingml/2006/main" xmlns:r="http://schemas.openxmlformats.org/officeDocument/2006/relationships" xmlns:p="http://schemas.openxmlformats.org/presentationml/2006/main">
   <p:cSld>
     <p:spTree>
       <p:nvGrpSpPr>
@@ -975,7 +769,7 @@
         <p:nvSpPr>
           <p:cNvPr id="2" name="Slide Image Placeholder 1"/>
           <p:cNvSpPr>
-            <a:spLocks noGrp="1"/>
+            <a:spLocks noGrp="1" noRot="1" noChangeAspect="1"/>
           </p:cNvSpPr>
           <p:nvPr>
             <p:ph type="sldImg" idx="2"/>
@@ -990,7 +784,7 @@
             <a:spLocks noGrp="1"/>
           </p:cNvSpPr>
           <p:nvPr>
-            <p:ph type="body" idx="3" sz="quarter"/>
+            <p:ph type="body" sz="quarter" idx="3"/>
           </p:nvPr>
         </p:nvSpPr>
         <p:spPr/>
@@ -1011,7 +805,7 @@
             <a:spLocks noGrp="1"/>
           </p:cNvSpPr>
           <p:nvPr>
-            <p:ph type="sldNum" idx="5" sz="quarter"/>
+            <p:ph type="sldNum" sz="quarter" idx="5"/>
           </p:nvPr>
         </p:nvSpPr>
         <p:spPr/>
@@ -1062,10 +856,9 @@
           <a:lstStyle/>
           <a:p>
             <a:r>
-              <a:rPr lang="en-US" smtClean="0"/>
+              <a:rPr lang="en-US"/>
               <a:t>Click to edit Master title style</a:t>
             </a:r>
-            <a:endParaRPr lang="en-US"/>
           </a:p>
         </p:txBody>
       </p:sp>
@@ -1181,10 +974,9 @@
           </a:lstStyle>
           <a:p>
             <a:r>
-              <a:rPr lang="en-US" smtClean="0"/>
+              <a:rPr lang="en-US"/>
               <a:t>Click to edit Master subtitle style</a:t>
             </a:r>
-            <a:endParaRPr lang="en-US"/>
           </a:p>
         </p:txBody>
       </p:sp>
@@ -1205,7 +997,7 @@
           <a:p>
             <a:fld id="{5BCAD085-E8A6-8845-BD4E-CB4CCA059FC4}" type="datetimeFigureOut">
               <a:rPr lang="en-US" smtClean="0"/>
-              <a:t>1/27/13</a:t>
+              <a:t>10/31/26</a:t>
             </a:fld>
             <a:endParaRPr lang="en-US"/>
           </a:p>
@@ -1299,10 +1091,9 @@
           <a:lstStyle/>
           <a:p>
             <a:r>
-              <a:rPr lang="en-US" smtClean="0"/>
+              <a:rPr lang="en-US"/>
               <a:t>Click to edit Master title style</a:t>
             </a:r>
-            <a:endParaRPr lang="en-US"/>
           </a:p>
         </p:txBody>
       </p:sp>
@@ -1323,38 +1114,37 @@
           <a:p>
             <a:pPr lvl="0"/>
             <a:r>
-              <a:rPr lang="en-US" smtClean="0"/>
+              <a:rPr lang="en-US"/>
               <a:t>Click to edit Master text styles</a:t>
             </a:r>
           </a:p>
           <a:p>
             <a:pPr lvl="1"/>
             <a:r>
-              <a:rPr lang="en-US" smtClean="0"/>
+              <a:rPr lang="en-US"/>
               <a:t>Second level</a:t>
             </a:r>
           </a:p>
           <a:p>
             <a:pPr lvl="2"/>
             <a:r>
-              <a:rPr lang="en-US" smtClean="0"/>
+              <a:rPr lang="en-US"/>
               <a:t>Third level</a:t>
             </a:r>
           </a:p>
           <a:p>
             <a:pPr lvl="3"/>
             <a:r>
-              <a:rPr lang="en-US" smtClean="0"/>
+              <a:rPr lang="en-US"/>
               <a:t>Fourth level</a:t>
             </a:r>
           </a:p>
           <a:p>
             <a:pPr lvl="4"/>
             <a:r>
-              <a:rPr lang="en-US" smtClean="0"/>
+              <a:rPr lang="en-US"/>
               <a:t>Fifth level</a:t>
             </a:r>
-            <a:endParaRPr lang="en-US"/>
           </a:p>
         </p:txBody>
       </p:sp>
@@ -1375,7 +1165,7 @@
           <a:p>
             <a:fld id="{5BCAD085-E8A6-8845-BD4E-CB4CCA059FC4}" type="datetimeFigureOut">
               <a:rPr lang="en-US" smtClean="0"/>
-              <a:t>1/27/13</a:t>
+              <a:t>10/31/26</a:t>
             </a:fld>
             <a:endParaRPr lang="en-US"/>
           </a:p>
@@ -1474,10 +1264,9 @@
           <a:lstStyle/>
           <a:p>
             <a:r>
-              <a:rPr lang="en-US" smtClean="0"/>
+              <a:rPr lang="en-US"/>
               <a:t>Click to edit Master title style</a:t>
             </a:r>
-            <a:endParaRPr lang="en-US"/>
           </a:p>
         </p:txBody>
       </p:sp>
@@ -1503,38 +1292,37 @@
           <a:p>
             <a:pPr lvl="0"/>
             <a:r>
-              <a:rPr lang="en-US" smtClean="0"/>
+              <a:rPr lang="en-US"/>
               <a:t>Click to edit Master text styles</a:t>
             </a:r>
           </a:p>
           <a:p>
             <a:pPr lvl="1"/>
             <a:r>
-              <a:rPr lang="en-US" smtClean="0"/>
+              <a:rPr lang="en-US"/>
               <a:t>Second level</a:t>
             </a:r>
           </a:p>
           <a:p>
             <a:pPr lvl="2"/>
             <a:r>
-              <a:rPr lang="en-US" smtClean="0"/>
+              <a:rPr lang="en-US"/>
               <a:t>Third level</a:t>
             </a:r>
           </a:p>
           <a:p>
             <a:pPr lvl="3"/>
             <a:r>
-              <a:rPr lang="en-US" smtClean="0"/>
+              <a:rPr lang="en-US"/>
               <a:t>Fourth level</a:t>
             </a:r>
           </a:p>
           <a:p>
             <a:pPr lvl="4"/>
             <a:r>
-              <a:rPr lang="en-US" smtClean="0"/>
+              <a:rPr lang="en-US"/>
               <a:t>Fifth level</a:t>
             </a:r>
-            <a:endParaRPr lang="en-US"/>
           </a:p>
         </p:txBody>
       </p:sp>
@@ -1555,7 +1343,7 @@
           <a:p>
             <a:fld id="{5BCAD085-E8A6-8845-BD4E-CB4CCA059FC4}" type="datetimeFigureOut">
               <a:rPr lang="en-US" smtClean="0"/>
-              <a:t>1/27/13</a:t>
+              <a:t>10/31/26</a:t>
             </a:fld>
             <a:endParaRPr lang="en-US"/>
           </a:p>
@@ -1649,10 +1437,9 @@
           <a:lstStyle/>
           <a:p>
             <a:r>
-              <a:rPr lang="en-US" smtClean="0"/>
+              <a:rPr lang="en-US"/>
               <a:t>Click to edit Master title style</a:t>
             </a:r>
-            <a:endParaRPr lang="en-US"/>
           </a:p>
         </p:txBody>
       </p:sp>
@@ -1673,38 +1460,37 @@
           <a:p>
             <a:pPr lvl="0"/>
             <a:r>
-              <a:rPr lang="en-US" smtClean="0"/>
+              <a:rPr lang="en-US"/>
               <a:t>Click to edit Master text styles</a:t>
             </a:r>
           </a:p>
           <a:p>
             <a:pPr lvl="1"/>
             <a:r>
-              <a:rPr lang="en-US" smtClean="0"/>
+              <a:rPr lang="en-US"/>
               <a:t>Second level</a:t>
             </a:r>
           </a:p>
           <a:p>
             <a:pPr lvl="2"/>
             <a:r>
-              <a:rPr lang="en-US" smtClean="0"/>
+              <a:rPr lang="en-US"/>
               <a:t>Third level</a:t>
             </a:r>
           </a:p>
           <a:p>
             <a:pPr lvl="3"/>
             <a:r>
-              <a:rPr lang="en-US" smtClean="0"/>
+              <a:rPr lang="en-US"/>
               <a:t>Fourth level</a:t>
             </a:r>
           </a:p>
           <a:p>
             <a:pPr lvl="4"/>
             <a:r>
-              <a:rPr lang="en-US" smtClean="0"/>
+              <a:rPr lang="en-US"/>
               <a:t>Fifth level</a:t>
             </a:r>
-            <a:endParaRPr lang="en-US"/>
           </a:p>
         </p:txBody>
       </p:sp>
@@ -1725,7 +1511,7 @@
           <a:p>
             <a:fld id="{5BCAD085-E8A6-8845-BD4E-CB4CCA059FC4}" type="datetimeFigureOut">
               <a:rPr lang="en-US" smtClean="0"/>
-              <a:t>1/27/13</a:t>
+              <a:t>10/31/26</a:t>
             </a:fld>
             <a:endParaRPr lang="en-US"/>
           </a:p>
@@ -1828,10 +1614,9 @@
           </a:lstStyle>
           <a:p>
             <a:r>
-              <a:rPr lang="en-US" smtClean="0"/>
+              <a:rPr lang="en-US"/>
               <a:t>Click to edit Master title style</a:t>
             </a:r>
-            <a:endParaRPr lang="en-US"/>
           </a:p>
         </p:txBody>
       </p:sp>
@@ -1948,7 +1733,7 @@
           <a:p>
             <a:pPr lvl="0"/>
             <a:r>
-              <a:rPr lang="en-US" smtClean="0"/>
+              <a:rPr lang="en-US"/>
               <a:t>Click to edit Master text styles</a:t>
             </a:r>
           </a:p>
@@ -1971,7 +1756,7 @@
           <a:p>
             <a:fld id="{5BCAD085-E8A6-8845-BD4E-CB4CCA059FC4}" type="datetimeFigureOut">
               <a:rPr lang="en-US" smtClean="0"/>
-              <a:t>1/27/13</a:t>
+              <a:t>10/31/26</a:t>
             </a:fld>
             <a:endParaRPr lang="en-US"/>
           </a:p>
@@ -2065,10 +1850,9 @@
           <a:lstStyle/>
           <a:p>
             <a:r>
-              <a:rPr lang="en-US" smtClean="0"/>
+              <a:rPr lang="en-US"/>
               <a:t>Click to edit Master title style</a:t>
             </a:r>
-            <a:endParaRPr lang="en-US"/>
           </a:p>
         </p:txBody>
       </p:sp>
@@ -2122,38 +1906,37 @@
           <a:p>
             <a:pPr lvl="0"/>
             <a:r>
-              <a:rPr lang="en-US" smtClean="0"/>
+              <a:rPr lang="en-US"/>
               <a:t>Click to edit Master text styles</a:t>
             </a:r>
           </a:p>
           <a:p>
             <a:pPr lvl="1"/>
             <a:r>
-              <a:rPr lang="en-US" smtClean="0"/>
+              <a:rPr lang="en-US"/>
               <a:t>Second level</a:t>
             </a:r>
           </a:p>
           <a:p>
             <a:pPr lvl="2"/>
             <a:r>
-              <a:rPr lang="en-US" smtClean="0"/>
+              <a:rPr lang="en-US"/>
               <a:t>Third level</a:t>
             </a:r>
           </a:p>
           <a:p>
             <a:pPr lvl="3"/>
             <a:r>
-              <a:rPr lang="en-US" smtClean="0"/>
+              <a:rPr lang="en-US"/>
               <a:t>Fourth level</a:t>
             </a:r>
           </a:p>
           <a:p>
             <a:pPr lvl="4"/>
             <a:r>
-              <a:rPr lang="en-US" smtClean="0"/>
+              <a:rPr lang="en-US"/>
               <a:t>Fifth level</a:t>
             </a:r>
-            <a:endParaRPr lang="en-US"/>
           </a:p>
         </p:txBody>
       </p:sp>
@@ -2207,38 +1990,37 @@
           <a:p>
             <a:pPr lvl="0"/>
             <a:r>
-              <a:rPr lang="en-US" smtClean="0"/>
+              <a:rPr lang="en-US"/>
               <a:t>Click to edit Master text styles</a:t>
             </a:r>
           </a:p>
           <a:p>
             <a:pPr lvl="1"/>
             <a:r>
-              <a:rPr lang="en-US" smtClean="0"/>
+              <a:rPr lang="en-US"/>
               <a:t>Second level</a:t>
             </a:r>
           </a:p>
           <a:p>
             <a:pPr lvl="2"/>
             <a:r>
-              <a:rPr lang="en-US" smtClean="0"/>
+              <a:rPr lang="en-US"/>
               <a:t>Third level</a:t>
             </a:r>
           </a:p>
           <a:p>
             <a:pPr lvl="3"/>
             <a:r>
-              <a:rPr lang="en-US" smtClean="0"/>
+              <a:rPr lang="en-US"/>
               <a:t>Fourth level</a:t>
             </a:r>
           </a:p>
           <a:p>
             <a:pPr lvl="4"/>
             <a:r>
-              <a:rPr lang="en-US" smtClean="0"/>
+              <a:rPr lang="en-US"/>
               <a:t>Fifth level</a:t>
             </a:r>
-            <a:endParaRPr lang="en-US"/>
           </a:p>
         </p:txBody>
       </p:sp>
@@ -2259,7 +2041,7 @@
           <a:p>
             <a:fld id="{5BCAD085-E8A6-8845-BD4E-CB4CCA059FC4}" type="datetimeFigureOut">
               <a:rPr lang="en-US" smtClean="0"/>
-              <a:t>1/27/13</a:t>
+              <a:t>10/31/26</a:t>
             </a:fld>
             <a:endParaRPr lang="en-US"/>
           </a:p>
@@ -2357,10 +2139,9 @@
           </a:lstStyle>
           <a:p>
             <a:r>
-              <a:rPr lang="en-US" smtClean="0"/>
+              <a:rPr lang="en-US"/>
               <a:t>Click to edit Master title style</a:t>
             </a:r>
-            <a:endParaRPr lang="en-US"/>
           </a:p>
         </p:txBody>
       </p:sp>
@@ -2423,7 +2204,7 @@
           <a:p>
             <a:pPr lvl="0"/>
             <a:r>
-              <a:rPr lang="en-US" smtClean="0"/>
+              <a:rPr lang="en-US"/>
               <a:t>Click to edit Master text styles</a:t>
             </a:r>
           </a:p>
@@ -2479,38 +2260,37 @@
           <a:p>
             <a:pPr lvl="0"/>
             <a:r>
-              <a:rPr lang="en-US" smtClean="0"/>
+              <a:rPr lang="en-US"/>
               <a:t>Click to edit Master text styles</a:t>
             </a:r>
           </a:p>
           <a:p>
             <a:pPr lvl="1"/>
             <a:r>
-              <a:rPr lang="en-US" smtClean="0"/>
+              <a:rPr lang="en-US"/>
               <a:t>Second level</a:t>
             </a:r>
           </a:p>
           <a:p>
             <a:pPr lvl="2"/>
             <a:r>
-              <a:rPr lang="en-US" smtClean="0"/>
+              <a:rPr lang="en-US"/>
               <a:t>Third level</a:t>
             </a:r>
           </a:p>
           <a:p>
             <a:pPr lvl="3"/>
             <a:r>
-              <a:rPr lang="en-US" smtClean="0"/>
+              <a:rPr lang="en-US"/>
               <a:t>Fourth level</a:t>
             </a:r>
           </a:p>
           <a:p>
             <a:pPr lvl="4"/>
             <a:r>
-              <a:rPr lang="en-US" smtClean="0"/>
+              <a:rPr lang="en-US"/>
               <a:t>Fifth level</a:t>
             </a:r>
-            <a:endParaRPr lang="en-US"/>
           </a:p>
         </p:txBody>
       </p:sp>
@@ -2573,7 +2353,7 @@
           <a:p>
             <a:pPr lvl="0"/>
             <a:r>
-              <a:rPr lang="en-US" smtClean="0"/>
+              <a:rPr lang="en-US"/>
               <a:t>Click to edit Master text styles</a:t>
             </a:r>
           </a:p>
@@ -2629,38 +2409,37 @@
           <a:p>
             <a:pPr lvl="0"/>
             <a:r>
-              <a:rPr lang="en-US" smtClean="0"/>
+              <a:rPr lang="en-US"/>
               <a:t>Click to edit Master text styles</a:t>
             </a:r>
           </a:p>
           <a:p>
             <a:pPr lvl="1"/>
             <a:r>
-              <a:rPr lang="en-US" smtClean="0"/>
+              <a:rPr lang="en-US"/>
               <a:t>Second level</a:t>
             </a:r>
           </a:p>
           <a:p>
             <a:pPr lvl="2"/>
             <a:r>
-              <a:rPr lang="en-US" smtClean="0"/>
+              <a:rPr lang="en-US"/>
               <a:t>Third level</a:t>
             </a:r>
           </a:p>
           <a:p>
             <a:pPr lvl="3"/>
             <a:r>
-              <a:rPr lang="en-US" smtClean="0"/>
+              <a:rPr lang="en-US"/>
               <a:t>Fourth level</a:t>
             </a:r>
           </a:p>
           <a:p>
             <a:pPr lvl="4"/>
             <a:r>
-              <a:rPr lang="en-US" smtClean="0"/>
+              <a:rPr lang="en-US"/>
               <a:t>Fifth level</a:t>
             </a:r>
-            <a:endParaRPr lang="en-US"/>
           </a:p>
         </p:txBody>
       </p:sp>
@@ -2681,7 +2460,7 @@
           <a:p>
             <a:fld id="{5BCAD085-E8A6-8845-BD4E-CB4CCA059FC4}" type="datetimeFigureOut">
               <a:rPr lang="en-US" smtClean="0"/>
-              <a:t>1/27/13</a:t>
+              <a:t>10/31/26</a:t>
             </a:fld>
             <a:endParaRPr lang="en-US"/>
           </a:p>
@@ -2775,10 +2554,9 @@
           <a:lstStyle/>
           <a:p>
             <a:r>
-              <a:rPr lang="en-US" smtClean="0"/>
+              <a:rPr lang="en-US"/>
               <a:t>Click to edit Master title style</a:t>
             </a:r>
-            <a:endParaRPr lang="en-US"/>
           </a:p>
         </p:txBody>
       </p:sp>
@@ -2799,7 +2577,7 @@
           <a:p>
             <a:fld id="{5BCAD085-E8A6-8845-BD4E-CB4CCA059FC4}" type="datetimeFigureOut">
               <a:rPr lang="en-US" smtClean="0"/>
-              <a:t>1/27/13</a:t>
+              <a:t>10/31/26</a:t>
             </a:fld>
             <a:endParaRPr lang="en-US"/>
           </a:p>
@@ -2894,7 +2672,7 @@
           <a:p>
             <a:fld id="{5BCAD085-E8A6-8845-BD4E-CB4CCA059FC4}" type="datetimeFigureOut">
               <a:rPr lang="en-US" smtClean="0"/>
-              <a:t>1/27/13</a:t>
+              <a:t>10/31/26</a:t>
             </a:fld>
             <a:endParaRPr lang="en-US"/>
           </a:p>
@@ -2997,10 +2775,9 @@
           </a:lstStyle>
           <a:p>
             <a:r>
-              <a:rPr lang="en-US" smtClean="0"/>
+              <a:rPr lang="en-US"/>
               <a:t>Click to edit Master title style</a:t>
             </a:r>
-            <a:endParaRPr lang="en-US"/>
           </a:p>
         </p:txBody>
       </p:sp>
@@ -3054,38 +2831,37 @@
           <a:p>
             <a:pPr lvl="0"/>
             <a:r>
-              <a:rPr lang="en-US" smtClean="0"/>
+              <a:rPr lang="en-US"/>
               <a:t>Click to edit Master text styles</a:t>
             </a:r>
           </a:p>
           <a:p>
             <a:pPr lvl="1"/>
             <a:r>
-              <a:rPr lang="en-US" smtClean="0"/>
+              <a:rPr lang="en-US"/>
               <a:t>Second level</a:t>
             </a:r>
           </a:p>
           <a:p>
             <a:pPr lvl="2"/>
             <a:r>
-              <a:rPr lang="en-US" smtClean="0"/>
+              <a:rPr lang="en-US"/>
               <a:t>Third level</a:t>
             </a:r>
           </a:p>
           <a:p>
             <a:pPr lvl="3"/>
             <a:r>
-              <a:rPr lang="en-US" smtClean="0"/>
+              <a:rPr lang="en-US"/>
               <a:t>Fourth level</a:t>
             </a:r>
           </a:p>
           <a:p>
             <a:pPr lvl="4"/>
             <a:r>
-              <a:rPr lang="en-US" smtClean="0"/>
+              <a:rPr lang="en-US"/>
               <a:t>Fifth level</a:t>
             </a:r>
-            <a:endParaRPr lang="en-US"/>
           </a:p>
         </p:txBody>
       </p:sp>
@@ -3148,7 +2924,7 @@
           <a:p>
             <a:pPr lvl="0"/>
             <a:r>
-              <a:rPr lang="en-US" smtClean="0"/>
+              <a:rPr lang="en-US"/>
               <a:t>Click to edit Master text styles</a:t>
             </a:r>
           </a:p>
@@ -3171,7 +2947,7 @@
           <a:p>
             <a:fld id="{5BCAD085-E8A6-8845-BD4E-CB4CCA059FC4}" type="datetimeFigureOut">
               <a:rPr lang="en-US" smtClean="0"/>
-              <a:t>1/27/13</a:t>
+              <a:t>10/31/26</a:t>
             </a:fld>
             <a:endParaRPr lang="en-US"/>
           </a:p>
@@ -3274,10 +3050,9 @@
           </a:lstStyle>
           <a:p>
             <a:r>
-              <a:rPr lang="en-US" smtClean="0"/>
+              <a:rPr lang="en-US"/>
               <a:t>Click to edit Master title style</a:t>
             </a:r>
-            <a:endParaRPr lang="en-US"/>
           </a:p>
         </p:txBody>
       </p:sp>
@@ -3401,7 +3176,7 @@
           <a:p>
             <a:pPr lvl="0"/>
             <a:r>
-              <a:rPr lang="en-US" smtClean="0"/>
+              <a:rPr lang="en-US"/>
               <a:t>Click to edit Master text styles</a:t>
             </a:r>
           </a:p>
@@ -3424,7 +3199,7 @@
           <a:p>
             <a:fld id="{5BCAD085-E8A6-8845-BD4E-CB4CCA059FC4}" type="datetimeFigureOut">
               <a:rPr lang="en-US" smtClean="0"/>
-              <a:t>1/27/13</a:t>
+              <a:t>10/31/26</a:t>
             </a:fld>
             <a:endParaRPr lang="en-US"/>
           </a:p>
@@ -3533,10 +3308,9 @@
           <a:lstStyle/>
           <a:p>
             <a:r>
-              <a:rPr lang="en-US" smtClean="0"/>
+              <a:rPr lang="en-US"/>
               <a:t>Click to edit Master title style</a:t>
             </a:r>
-            <a:endParaRPr lang="en-US"/>
           </a:p>
         </p:txBody>
       </p:sp>
@@ -3567,38 +3341,37 @@
           <a:p>
             <a:pPr lvl="0"/>
             <a:r>
-              <a:rPr lang="en-US" smtClean="0"/>
+              <a:rPr lang="en-US"/>
               <a:t>Click to edit Master text styles</a:t>
             </a:r>
           </a:p>
           <a:p>
             <a:pPr lvl="1"/>
             <a:r>
-              <a:rPr lang="en-US" smtClean="0"/>
+              <a:rPr lang="en-US"/>
               <a:t>Second level</a:t>
             </a:r>
           </a:p>
           <a:p>
             <a:pPr lvl="2"/>
             <a:r>
-              <a:rPr lang="en-US" smtClean="0"/>
+              <a:rPr lang="en-US"/>
               <a:t>Third level</a:t>
             </a:r>
           </a:p>
           <a:p>
             <a:pPr lvl="3"/>
             <a:r>
-              <a:rPr lang="en-US" smtClean="0"/>
+              <a:rPr lang="en-US"/>
               <a:t>Fourth level</a:t>
             </a:r>
           </a:p>
           <a:p>
             <a:pPr lvl="4"/>
             <a:r>
-              <a:rPr lang="en-US" smtClean="0"/>
+              <a:rPr lang="en-US"/>
               <a:t>Fifth level</a:t>
             </a:r>
-            <a:endParaRPr lang="en-US"/>
           </a:p>
         </p:txBody>
       </p:sp>
@@ -3637,7 +3410,7 @@
           <a:p>
             <a:fld id="{5BCAD085-E8A6-8845-BD4E-CB4CCA059FC4}" type="datetimeFigureOut">
               <a:rPr lang="en-US" smtClean="0"/>
-              <a:t>1/27/13</a:t>
+              <a:t>10/31/26</a:t>
             </a:fld>
             <a:endParaRPr lang="en-US"/>
           </a:p>
@@ -3996,7 +3769,7 @@
 </file>
 
 <file path=ppt/slides/slide1.xml><?xml version="1.0" encoding="utf-8"?>
-<p:sld xmlns:a="http://schemas.openxmlformats.org/drawingml/2006/main" xmlns:p="http://schemas.openxmlformats.org/presentationml/2006/main" xmlns:r="http://schemas.openxmlformats.org/officeDocument/2006/relationships">
+<p:sld xmlns:a="http://schemas.openxmlformats.org/drawingml/2006/main" xmlns:r="http://schemas.openxmlformats.org/officeDocument/2006/relationships" xmlns:p="http://schemas.openxmlformats.org/presentationml/2006/main">
   <p:cSld>
     <p:spTree>
       <p:nvGrpSpPr>
@@ -4004,7 +3777,14 @@
         <p:cNvGrpSpPr/>
         <p:nvPr/>
       </p:nvGrpSpPr>
-      <p:grpSpPr/>
+      <p:grpSpPr>
+        <a:xfrm>
+          <a:off x="0" y="0"/>
+          <a:ext cx="0" cy="0"/>
+          <a:chOff x="0" y="0"/>
+          <a:chExt cx="0" cy="0"/>
+        </a:xfrm>
+      </p:grpSpPr>
       <p:sp>
         <p:nvSpPr>
           <p:cNvPr id="2" name="Rectangle 1"/>
@@ -4046,6 +3826,7 @@
           <a:lstStyle/>
           <a:p>
             <a:pPr algn="ctr"/>
+            <a:endParaRPr/>
           </a:p>
         </p:txBody>
       </p:sp>
@@ -4066,7 +3847,7 @@
           <a:noFill/>
         </p:spPr>
         <p:txBody>
-          <a:bodyPr wrap="square" anchor="t" lIns="45720" rIns="45720" tIns="27432" bIns="27432">
+          <a:bodyPr wrap="square" lIns="45720" tIns="27432" rIns="45720" bIns="27432" anchor="t">
             <a:spAutoFit/>
           </a:bodyPr>
           <a:lstStyle/>
@@ -4105,7 +3886,7 @@
           <a:noFill/>
         </p:spPr>
         <p:txBody>
-          <a:bodyPr wrap="square" anchor="t" lIns="45720" rIns="45720" tIns="27432" bIns="27432">
+          <a:bodyPr wrap="square" lIns="45720" tIns="27432" rIns="45720" bIns="27432" anchor="t">
             <a:spAutoFit/>
           </a:bodyPr>
           <a:lstStyle/>
@@ -4168,6 +3949,7 @@
           <a:lstStyle/>
           <a:p>
             <a:pPr algn="ctr"/>
+            <a:endParaRPr/>
           </a:p>
         </p:txBody>
       </p:sp>
@@ -4188,7 +3970,7 @@
           <a:noFill/>
         </p:spPr>
         <p:txBody>
-          <a:bodyPr wrap="square" anchor="t" lIns="45720" rIns="45720" tIns="27432" bIns="27432">
+          <a:bodyPr wrap="square" lIns="45720" tIns="27432" rIns="45720" bIns="27432" anchor="t">
             <a:spAutoFit/>
           </a:bodyPr>
           <a:lstStyle/>
@@ -4227,7 +4009,7 @@
           <a:noFill/>
         </p:spPr>
         <p:txBody>
-          <a:bodyPr wrap="square" anchor="t" lIns="45720" rIns="45720" tIns="27432" bIns="27432">
+          <a:bodyPr wrap="square" lIns="45720" tIns="27432" rIns="45720" bIns="27432" anchor="t">
             <a:spAutoFit/>
           </a:bodyPr>
           <a:lstStyle/>
@@ -4290,6 +4072,7 @@
           <a:lstStyle/>
           <a:p>
             <a:pPr algn="ctr"/>
+            <a:endParaRPr/>
           </a:p>
         </p:txBody>
       </p:sp>
@@ -4310,7 +4093,7 @@
           <a:noFill/>
         </p:spPr>
         <p:txBody>
-          <a:bodyPr wrap="square" anchor="t" lIns="45720" rIns="45720" tIns="27432" bIns="27432">
+          <a:bodyPr wrap="square" lIns="45720" tIns="27432" rIns="45720" bIns="27432" anchor="t">
             <a:spAutoFit/>
           </a:bodyPr>
           <a:lstStyle/>
@@ -4349,7 +4132,7 @@
           <a:noFill/>
         </p:spPr>
         <p:txBody>
-          <a:bodyPr wrap="square" anchor="t" lIns="45720" rIns="45720" tIns="27432" bIns="27432">
+          <a:bodyPr wrap="square" lIns="45720" tIns="27432" rIns="45720" bIns="27432" anchor="t">
             <a:spAutoFit/>
           </a:bodyPr>
           <a:lstStyle/>
@@ -4412,6 +4195,7 @@
           <a:lstStyle/>
           <a:p>
             <a:pPr algn="ctr"/>
+            <a:endParaRPr/>
           </a:p>
         </p:txBody>
       </p:sp>
@@ -4432,7 +4216,7 @@
           <a:noFill/>
         </p:spPr>
         <p:txBody>
-          <a:bodyPr wrap="square" anchor="t" lIns="45720" rIns="45720" tIns="27432" bIns="27432">
+          <a:bodyPr wrap="square" lIns="45720" tIns="27432" rIns="45720" bIns="27432" anchor="t">
             <a:spAutoFit/>
           </a:bodyPr>
           <a:lstStyle/>
@@ -4471,7 +4255,7 @@
           <a:noFill/>
         </p:spPr>
         <p:txBody>
-          <a:bodyPr wrap="square" anchor="t" lIns="45720" rIns="45720" tIns="27432" bIns="27432">
+          <a:bodyPr wrap="square" lIns="45720" tIns="27432" rIns="45720" bIns="27432" anchor="t">
             <a:spAutoFit/>
           </a:bodyPr>
           <a:lstStyle/>
@@ -4534,6 +4318,7 @@
           <a:lstStyle/>
           <a:p>
             <a:pPr algn="ctr"/>
+            <a:endParaRPr/>
           </a:p>
         </p:txBody>
       </p:sp>
@@ -4554,7 +4339,7 @@
           <a:noFill/>
         </p:spPr>
         <p:txBody>
-          <a:bodyPr wrap="square" anchor="t" lIns="45720" rIns="45720" tIns="27432" bIns="27432">
+          <a:bodyPr wrap="square" lIns="45720" tIns="27432" rIns="45720" bIns="27432" anchor="t">
             <a:spAutoFit/>
           </a:bodyPr>
           <a:lstStyle/>
@@ -4593,7 +4378,7 @@
           <a:noFill/>
         </p:spPr>
         <p:txBody>
-          <a:bodyPr wrap="square" anchor="t" lIns="45720" rIns="45720" tIns="27432" bIns="27432">
+          <a:bodyPr wrap="square" lIns="45720" tIns="27432" rIns="45720" bIns="27432" anchor="t">
             <a:spAutoFit/>
           </a:bodyPr>
           <a:lstStyle/>
@@ -4632,7 +4417,7 @@
           <a:noFill/>
         </p:spPr>
         <p:txBody>
-          <a:bodyPr wrap="square" anchor="t" lIns="45720" rIns="45720" tIns="27432" bIns="27432">
+          <a:bodyPr wrap="square" lIns="45720" tIns="27432" rIns="45720" bIns="27432" anchor="t">
             <a:spAutoFit/>
           </a:bodyPr>
           <a:lstStyle/>
@@ -4679,7 +4464,7 @@
           <p:nvPr/>
         </p:nvPicPr>
         <p:blipFill>
-          <a:blip r:embed="rId2"/>
+          <a:blip r:embed="rId3"/>
           <a:stretch>
             <a:fillRect/>
           </a:stretch>
@@ -4711,7 +4496,7 @@
           <a:noFill/>
         </p:spPr>
         <p:txBody>
-          <a:bodyPr wrap="square" anchor="t" lIns="45720" rIns="45720" tIns="27432" bIns="27432">
+          <a:bodyPr wrap="square" lIns="45720" tIns="27432" rIns="45720" bIns="27432" anchor="t">
             <a:spAutoFit/>
           </a:bodyPr>
           <a:lstStyle/>
@@ -4742,7 +4527,7 @@
 </file>
 
 <file path=ppt/slides/slide2.xml><?xml version="1.0" encoding="utf-8"?>
-<p:sld xmlns:a="http://schemas.openxmlformats.org/drawingml/2006/main" xmlns:p="http://schemas.openxmlformats.org/presentationml/2006/main" xmlns:r="http://schemas.openxmlformats.org/officeDocument/2006/relationships">
+<p:sld xmlns:a="http://schemas.openxmlformats.org/drawingml/2006/main" xmlns:r="http://schemas.openxmlformats.org/officeDocument/2006/relationships" xmlns:p="http://schemas.openxmlformats.org/presentationml/2006/main">
   <p:cSld>
     <p:spTree>
       <p:nvGrpSpPr>
@@ -4750,7 +4535,14 @@
         <p:cNvGrpSpPr/>
         <p:nvPr/>
       </p:nvGrpSpPr>
-      <p:grpSpPr/>
+      <p:grpSpPr>
+        <a:xfrm>
+          <a:off x="0" y="0"/>
+          <a:ext cx="0" cy="0"/>
+          <a:chOff x="0" y="0"/>
+          <a:chExt cx="0" cy="0"/>
+        </a:xfrm>
+      </p:grpSpPr>
       <p:sp>
         <p:nvSpPr>
           <p:cNvPr id="2" name="TextBox 1"/>
@@ -4768,7 +4560,7 @@
           <a:noFill/>
         </p:spPr>
         <p:txBody>
-          <a:bodyPr wrap="square" anchor="t" lIns="45720" rIns="45720" tIns="27432" bIns="27432">
+          <a:bodyPr wrap="square" lIns="45720" tIns="27432" rIns="45720" bIns="27432" anchor="t">
             <a:spAutoFit/>
           </a:bodyPr>
           <a:lstStyle/>
@@ -4799,7 +4591,7 @@
           <p:nvPr/>
         </p:nvPicPr>
         <p:blipFill>
-          <a:blip r:embed="rId2"/>
+          <a:blip r:embed="rId3"/>
           <a:stretch>
             <a:fillRect/>
           </a:stretch>
@@ -4831,7 +4623,7 @@
           <a:noFill/>
         </p:spPr>
         <p:txBody>
-          <a:bodyPr wrap="square" anchor="t" lIns="45720" rIns="45720" tIns="27432" bIns="27432">
+          <a:bodyPr wrap="square" lIns="45720" tIns="27432" rIns="45720" bIns="27432" anchor="t">
             <a:spAutoFit/>
           </a:bodyPr>
           <a:lstStyle/>
@@ -4910,6 +4702,7 @@
           <a:lstStyle/>
           <a:p>
             <a:pPr algn="ctr"/>
+            <a:endParaRPr/>
           </a:p>
         </p:txBody>
       </p:sp>
@@ -4930,7 +4723,7 @@
           <a:noFill/>
         </p:spPr>
         <p:txBody>
-          <a:bodyPr wrap="square" anchor="t" lIns="45720" rIns="45720" tIns="27432" bIns="27432">
+          <a:bodyPr wrap="square" lIns="45720" tIns="27432" rIns="45720" bIns="27432" anchor="t">
             <a:spAutoFit/>
           </a:bodyPr>
           <a:lstStyle/>
@@ -4969,7 +4762,7 @@
           <a:noFill/>
         </p:spPr>
         <p:txBody>
-          <a:bodyPr wrap="square" anchor="t" lIns="45720" rIns="45720" tIns="27432" bIns="27432">
+          <a:bodyPr wrap="square" lIns="45720" tIns="27432" rIns="45720" bIns="27432" anchor="t">
             <a:spAutoFit/>
           </a:bodyPr>
           <a:lstStyle/>
@@ -5064,7 +4857,7 @@
 </file>
 
 <file path=ppt/slides/slide3.xml><?xml version="1.0" encoding="utf-8"?>
-<p:sld xmlns:a="http://schemas.openxmlformats.org/drawingml/2006/main" xmlns:p="http://schemas.openxmlformats.org/presentationml/2006/main" xmlns:r="http://schemas.openxmlformats.org/officeDocument/2006/relationships">
+<p:sld xmlns:a="http://schemas.openxmlformats.org/drawingml/2006/main" xmlns:r="http://schemas.openxmlformats.org/officeDocument/2006/relationships" xmlns:p="http://schemas.openxmlformats.org/presentationml/2006/main">
   <p:cSld>
     <p:spTree>
       <p:nvGrpSpPr>
@@ -5072,7 +4865,14 @@
         <p:cNvGrpSpPr/>
         <p:nvPr/>
       </p:nvGrpSpPr>
-      <p:grpSpPr/>
+      <p:grpSpPr>
+        <a:xfrm>
+          <a:off x="0" y="0"/>
+          <a:ext cx="0" cy="0"/>
+          <a:chOff x="0" y="0"/>
+          <a:chExt cx="0" cy="0"/>
+        </a:xfrm>
+      </p:grpSpPr>
       <p:sp>
         <p:nvSpPr>
           <p:cNvPr id="2" name="TextBox 1"/>
@@ -5081,8 +4881,8 @@
         </p:nvSpPr>
         <p:spPr>
           <a:xfrm>
-            <a:off x="548640" y="365760"/>
-            <a:ext cx="11094415" cy="685800"/>
+            <a:off x="278053" y="325090"/>
+            <a:ext cx="11094415" cy="486287"/>
           </a:xfrm>
           <a:prstGeom prst="rect">
             <a:avLst/>
@@ -5090,7 +4890,7 @@
           <a:noFill/>
         </p:spPr>
         <p:txBody>
-          <a:bodyPr wrap="square" anchor="t" lIns="45720" rIns="45720" tIns="27432" bIns="27432">
+          <a:bodyPr wrap="square" lIns="45720" tIns="27432" rIns="45720" bIns="27432" anchor="t">
             <a:spAutoFit/>
           </a:bodyPr>
           <a:lstStyle/>
@@ -5101,13 +4901,31 @@
               </a:spcAft>
             </a:pPr>
             <a:r>
-              <a:rPr sz="2800" b="1">
+              <a:rPr sz="2800" b="1" dirty="0">
                 <a:solidFill>
                   <a:srgbClr val="0A4A4A"/>
                 </a:solidFill>
                 <a:latin typeface="Cambria"/>
               </a:rPr>
-              <a:t>The new line: her notes set the rules, the data sets the numbers</a:t>
+              <a:t>The new line: </a:t>
+            </a:r>
+            <a:r>
+              <a:rPr lang="en-US" sz="2800" b="1" dirty="0">
+                <a:solidFill>
+                  <a:srgbClr val="0A4A4A"/>
+                </a:solidFill>
+                <a:latin typeface="Cambria"/>
+              </a:rPr>
+              <a:t>policy</a:t>
+            </a:r>
+            <a:r>
+              <a:rPr sz="2800" b="1" dirty="0">
+                <a:solidFill>
+                  <a:srgbClr val="0A4A4A"/>
+                </a:solidFill>
+                <a:latin typeface="Cambria"/>
+              </a:rPr>
+              <a:t> notes set the rules, the data sets the numbers</a:t>
             </a:r>
           </a:p>
         </p:txBody>
@@ -5122,7 +4940,7 @@
         </p:nvGraphicFramePr>
         <p:xfrm>
           <a:off x="548640" y="1234440"/>
-          <a:ext cx="5440680" cy="2048256"/>
+          <a:ext cx="5440680" cy="2383536"/>
         </p:xfrm>
         <a:graphic>
           <a:graphicData uri="http://schemas.openxmlformats.org/drawingml/2006/table">
@@ -5131,8 +4949,20 @@
                 <a:tableStyleId>{5C22544A-7EE6-4342-B048-85BDC9FD1C3A}</a:tableStyleId>
               </a:tblPr>
               <a:tblGrid>
-                <a:gridCol w="2514600"/>
-                <a:gridCol w="2926080"/>
+                <a:gridCol w="2514600">
+                  <a:extLst>
+                    <a:ext uri="{9D8B030D-6E8A-4147-A177-3AD203B41FA5}">
+                      <a16:colId xmlns:a16="http://schemas.microsoft.com/office/drawing/2014/main" val="20000"/>
+                    </a:ext>
+                  </a:extLst>
+                </a:gridCol>
+                <a:gridCol w="2926080">
+                  <a:extLst>
+                    <a:ext uri="{9D8B030D-6E8A-4147-A177-3AD203B41FA5}">
+                      <a16:colId xmlns:a16="http://schemas.microsoft.com/office/drawing/2014/main" val="20001"/>
+                    </a:ext>
+                  </a:extLst>
+                </a:gridCol>
               </a:tblGrid>
               <a:tr h="292608">
                 <a:tc>
@@ -5183,6 +5013,11 @@
                     </a:solidFill>
                   </a:tcPr>
                 </a:tc>
+                <a:extLst>
+                  <a:ext uri="{0D108BD9-81ED-4DB2-BD59-A6C34878D82A}">
+                    <a16:rowId xmlns:a16="http://schemas.microsoft.com/office/drawing/2014/main" val="10000"/>
+                  </a:ext>
+                </a:extLst>
               </a:tr>
               <a:tr h="292608">
                 <a:tc>
@@ -5233,6 +5068,11 @@
                     </a:solidFill>
                   </a:tcPr>
                 </a:tc>
+                <a:extLst>
+                  <a:ext uri="{0D108BD9-81ED-4DB2-BD59-A6C34878D82A}">
+                    <a16:rowId xmlns:a16="http://schemas.microsoft.com/office/drawing/2014/main" val="10001"/>
+                  </a:ext>
+                </a:extLst>
               </a:tr>
               <a:tr h="292608">
                 <a:tc>
@@ -5283,6 +5123,11 @@
                     </a:solidFill>
                   </a:tcPr>
                 </a:tc>
+                <a:extLst>
+                  <a:ext uri="{0D108BD9-81ED-4DB2-BD59-A6C34878D82A}">
+                    <a16:rowId xmlns:a16="http://schemas.microsoft.com/office/drawing/2014/main" val="10002"/>
+                  </a:ext>
+                </a:extLst>
               </a:tr>
               <a:tr h="292608">
                 <a:tc>
@@ -5333,6 +5178,11 @@
                     </a:solidFill>
                   </a:tcPr>
                 </a:tc>
+                <a:extLst>
+                  <a:ext uri="{0D108BD9-81ED-4DB2-BD59-A6C34878D82A}">
+                    <a16:rowId xmlns:a16="http://schemas.microsoft.com/office/drawing/2014/main" val="10003"/>
+                  </a:ext>
+                </a:extLst>
               </a:tr>
               <a:tr h="292608">
                 <a:tc>
@@ -5383,6 +5233,11 @@
                     </a:solidFill>
                   </a:tcPr>
                 </a:tc>
+                <a:extLst>
+                  <a:ext uri="{0D108BD9-81ED-4DB2-BD59-A6C34878D82A}">
+                    <a16:rowId xmlns:a16="http://schemas.microsoft.com/office/drawing/2014/main" val="10004"/>
+                  </a:ext>
+                </a:extLst>
               </a:tr>
               <a:tr h="292608">
                 <a:tc>
@@ -5433,6 +5288,11 @@
                     </a:solidFill>
                   </a:tcPr>
                 </a:tc>
+                <a:extLst>
+                  <a:ext uri="{0D108BD9-81ED-4DB2-BD59-A6C34878D82A}">
+                    <a16:rowId xmlns:a16="http://schemas.microsoft.com/office/drawing/2014/main" val="10005"/>
+                  </a:ext>
+                </a:extLst>
               </a:tr>
               <a:tr h="292608">
                 <a:tc>
@@ -5483,6 +5343,11 @@
                     </a:solidFill>
                   </a:tcPr>
                 </a:tc>
+                <a:extLst>
+                  <a:ext uri="{0D108BD9-81ED-4DB2-BD59-A6C34878D82A}">
+                    <a16:rowId xmlns:a16="http://schemas.microsoft.com/office/drawing/2014/main" val="10006"/>
+                  </a:ext>
+                </a:extLst>
               </a:tr>
             </a:tbl>
           </a:graphicData>
@@ -5505,7 +5370,7 @@
           <a:noFill/>
         </p:spPr>
         <p:txBody>
-          <a:bodyPr wrap="square" anchor="t" lIns="45720" rIns="45720" tIns="27432" bIns="27432">
+          <a:bodyPr wrap="square" lIns="45720" tIns="27432" rIns="45720" bIns="27432" anchor="t">
             <a:spAutoFit/>
           </a:bodyPr>
           <a:lstStyle/>
@@ -5532,7 +5397,7 @@
               </a:spcAft>
             </a:pPr>
             <a:r>
-              <a:rPr sz="1200" b="0">
+              <a:rPr sz="1200" b="0" dirty="0">
                 <a:solidFill>
                   <a:srgbClr val="1B1B1B"/>
                 </a:solidFill>
@@ -5548,7 +5413,7 @@
               </a:spcAft>
             </a:pPr>
             <a:r>
-              <a:rPr sz="1200" b="0">
+              <a:rPr sz="1200" b="0" dirty="0">
                 <a:solidFill>
                   <a:srgbClr val="1B1B1B"/>
                 </a:solidFill>
@@ -5568,7 +5433,7 @@
           <p:nvPr/>
         </p:nvPicPr>
         <p:blipFill>
-          <a:blip r:embed="rId2"/>
+          <a:blip r:embed="rId3"/>
           <a:stretch>
             <a:fillRect/>
           </a:stretch>
@@ -5600,7 +5465,7 @@
           <a:noFill/>
         </p:spPr>
         <p:txBody>
-          <a:bodyPr wrap="square" anchor="t" lIns="45720" rIns="45720" tIns="27432" bIns="27432">
+          <a:bodyPr wrap="square" lIns="45720" tIns="27432" rIns="45720" bIns="27432" anchor="t">
             <a:spAutoFit/>
           </a:bodyPr>
           <a:lstStyle/>
@@ -5632,7 +5497,7 @@
         </p:nvGraphicFramePr>
         <p:xfrm>
           <a:off x="6217920" y="4050029"/>
-          <a:ext cx="5440680" cy="1463040"/>
+          <a:ext cx="5440680" cy="1530096"/>
         </p:xfrm>
         <a:graphic>
           <a:graphicData uri="http://schemas.openxmlformats.org/drawingml/2006/table">
@@ -5641,10 +5506,34 @@
                 <a:tableStyleId>{5C22544A-7EE6-4342-B048-85BDC9FD1C3A}</a:tableStyleId>
               </a:tblPr>
               <a:tblGrid>
-                <a:gridCol w="1188720"/>
-                <a:gridCol w="1188720"/>
-                <a:gridCol w="1417320"/>
-                <a:gridCol w="1645920"/>
+                <a:gridCol w="1188720">
+                  <a:extLst>
+                    <a:ext uri="{9D8B030D-6E8A-4147-A177-3AD203B41FA5}">
+                      <a16:colId xmlns:a16="http://schemas.microsoft.com/office/drawing/2014/main" val="20000"/>
+                    </a:ext>
+                  </a:extLst>
+                </a:gridCol>
+                <a:gridCol w="1188720">
+                  <a:extLst>
+                    <a:ext uri="{9D8B030D-6E8A-4147-A177-3AD203B41FA5}">
+                      <a16:colId xmlns:a16="http://schemas.microsoft.com/office/drawing/2014/main" val="20001"/>
+                    </a:ext>
+                  </a:extLst>
+                </a:gridCol>
+                <a:gridCol w="1417320">
+                  <a:extLst>
+                    <a:ext uri="{9D8B030D-6E8A-4147-A177-3AD203B41FA5}">
+                      <a16:colId xmlns:a16="http://schemas.microsoft.com/office/drawing/2014/main" val="20002"/>
+                    </a:ext>
+                  </a:extLst>
+                </a:gridCol>
+                <a:gridCol w="1645920">
+                  <a:extLst>
+                    <a:ext uri="{9D8B030D-6E8A-4147-A177-3AD203B41FA5}">
+                      <a16:colId xmlns:a16="http://schemas.microsoft.com/office/drawing/2014/main" val="20003"/>
+                    </a:ext>
+                  </a:extLst>
+                </a:gridCol>
               </a:tblGrid>
               <a:tr h="292608">
                 <a:tc>
@@ -5743,6 +5632,11 @@
                     </a:solidFill>
                   </a:tcPr>
                 </a:tc>
+                <a:extLst>
+                  <a:ext uri="{0D108BD9-81ED-4DB2-BD59-A6C34878D82A}">
+                    <a16:rowId xmlns:a16="http://schemas.microsoft.com/office/drawing/2014/main" val="10000"/>
+                  </a:ext>
+                </a:extLst>
               </a:tr>
               <a:tr h="292608">
                 <a:tc>
@@ -5841,6 +5735,11 @@
                     </a:solidFill>
                   </a:tcPr>
                 </a:tc>
+                <a:extLst>
+                  <a:ext uri="{0D108BD9-81ED-4DB2-BD59-A6C34878D82A}">
+                    <a16:rowId xmlns:a16="http://schemas.microsoft.com/office/drawing/2014/main" val="10001"/>
+                  </a:ext>
+                </a:extLst>
               </a:tr>
               <a:tr h="292608">
                 <a:tc>
@@ -5939,6 +5838,11 @@
                     </a:solidFill>
                   </a:tcPr>
                 </a:tc>
+                <a:extLst>
+                  <a:ext uri="{0D108BD9-81ED-4DB2-BD59-A6C34878D82A}">
+                    <a16:rowId xmlns:a16="http://schemas.microsoft.com/office/drawing/2014/main" val="10002"/>
+                  </a:ext>
+                </a:extLst>
               </a:tr>
               <a:tr h="292608">
                 <a:tc>
@@ -6037,6 +5941,11 @@
                     </a:solidFill>
                   </a:tcPr>
                 </a:tc>
+                <a:extLst>
+                  <a:ext uri="{0D108BD9-81ED-4DB2-BD59-A6C34878D82A}">
+                    <a16:rowId xmlns:a16="http://schemas.microsoft.com/office/drawing/2014/main" val="10003"/>
+                  </a:ext>
+                </a:extLst>
               </a:tr>
               <a:tr h="292608">
                 <a:tc>
@@ -6135,6 +6044,11 @@
                     </a:solidFill>
                   </a:tcPr>
                 </a:tc>
+                <a:extLst>
+                  <a:ext uri="{0D108BD9-81ED-4DB2-BD59-A6C34878D82A}">
+                    <a16:rowId xmlns:a16="http://schemas.microsoft.com/office/drawing/2014/main" val="10004"/>
+                  </a:ext>
+                </a:extLst>
               </a:tr>
             </a:tbl>
           </a:graphicData>
@@ -6157,7 +6071,7 @@
           <a:noFill/>
         </p:spPr>
         <p:txBody>
-          <a:bodyPr wrap="square" anchor="t" lIns="45720" rIns="45720" tIns="27432" bIns="27432">
+          <a:bodyPr wrap="square" lIns="45720" tIns="27432" rIns="45720" bIns="27432" anchor="t">
             <a:spAutoFit/>
           </a:bodyPr>
           <a:lstStyle/>
@@ -6188,7 +6102,7 @@
 </file>
 
 <file path=ppt/slides/slide4.xml><?xml version="1.0" encoding="utf-8"?>
-<p:sld xmlns:a="http://schemas.openxmlformats.org/drawingml/2006/main" xmlns:p="http://schemas.openxmlformats.org/presentationml/2006/main" xmlns:r="http://schemas.openxmlformats.org/officeDocument/2006/relationships">
+<p:sld xmlns:a="http://schemas.openxmlformats.org/drawingml/2006/main" xmlns:r="http://schemas.openxmlformats.org/officeDocument/2006/relationships" xmlns:p="http://schemas.openxmlformats.org/presentationml/2006/main">
   <p:cSld>
     <p:spTree>
       <p:nvGrpSpPr>
@@ -6196,7 +6110,14 @@
         <p:cNvGrpSpPr/>
         <p:nvPr/>
       </p:nvGrpSpPr>
-      <p:grpSpPr/>
+      <p:grpSpPr>
+        <a:xfrm>
+          <a:off x="0" y="0"/>
+          <a:ext cx="0" cy="0"/>
+          <a:chOff x="0" y="0"/>
+          <a:chExt cx="0" cy="0"/>
+        </a:xfrm>
+      </p:grpSpPr>
       <p:sp>
         <p:nvSpPr>
           <p:cNvPr id="2" name="TextBox 1"/>
@@ -6214,7 +6135,7 @@
           <a:noFill/>
         </p:spPr>
         <p:txBody>
-          <a:bodyPr wrap="square" anchor="t" lIns="45720" rIns="45720" tIns="27432" bIns="27432">
+          <a:bodyPr wrap="square" lIns="45720" tIns="27432" rIns="45720" bIns="27432" anchor="t">
             <a:spAutoFit/>
           </a:bodyPr>
           <a:lstStyle/>
@@ -6277,6 +6198,7 @@
           <a:lstStyle/>
           <a:p>
             <a:pPr algn="ctr"/>
+            <a:endParaRPr/>
           </a:p>
         </p:txBody>
       </p:sp>
@@ -6297,7 +6219,7 @@
           <a:noFill/>
         </p:spPr>
         <p:txBody>
-          <a:bodyPr wrap="square" anchor="t" lIns="45720" rIns="45720" tIns="27432" bIns="27432">
+          <a:bodyPr wrap="square" lIns="45720" tIns="27432" rIns="45720" bIns="27432" anchor="t">
             <a:spAutoFit/>
           </a:bodyPr>
           <a:lstStyle/>
@@ -6376,6 +6298,7 @@
           <a:lstStyle/>
           <a:p>
             <a:pPr algn="ctr"/>
+            <a:endParaRPr/>
           </a:p>
         </p:txBody>
       </p:sp>
@@ -6420,6 +6343,7 @@
           <a:lstStyle/>
           <a:p>
             <a:pPr algn="ctr"/>
+            <a:endParaRPr/>
           </a:p>
         </p:txBody>
       </p:sp>
@@ -6440,7 +6364,7 @@
           <a:noFill/>
         </p:spPr>
         <p:txBody>
-          <a:bodyPr wrap="square" anchor="t" lIns="45720" rIns="45720" tIns="27432" bIns="27432">
+          <a:bodyPr wrap="square" lIns="45720" tIns="27432" rIns="45720" bIns="27432" anchor="t">
             <a:spAutoFit/>
           </a:bodyPr>
           <a:lstStyle/>
@@ -6519,6 +6443,7 @@
           <a:lstStyle/>
           <a:p>
             <a:pPr algn="ctr"/>
+            <a:endParaRPr/>
           </a:p>
         </p:txBody>
       </p:sp>
@@ -6563,6 +6488,7 @@
           <a:lstStyle/>
           <a:p>
             <a:pPr algn="ctr"/>
+            <a:endParaRPr/>
           </a:p>
         </p:txBody>
       </p:sp>
@@ -6583,7 +6509,7 @@
           <a:noFill/>
         </p:spPr>
         <p:txBody>
-          <a:bodyPr wrap="square" anchor="t" lIns="45720" rIns="45720" tIns="27432" bIns="27432">
+          <a:bodyPr wrap="square" lIns="45720" tIns="27432" rIns="45720" bIns="27432" anchor="t">
             <a:spAutoFit/>
           </a:bodyPr>
           <a:lstStyle/>
@@ -6662,6 +6588,7 @@
           <a:lstStyle/>
           <a:p>
             <a:pPr algn="ctr"/>
+            <a:endParaRPr/>
           </a:p>
         </p:txBody>
       </p:sp>
@@ -6706,6 +6633,7 @@
           <a:lstStyle/>
           <a:p>
             <a:pPr algn="ctr"/>
+            <a:endParaRPr/>
           </a:p>
         </p:txBody>
       </p:sp>
@@ -6726,7 +6654,7 @@
           <a:noFill/>
         </p:spPr>
         <p:txBody>
-          <a:bodyPr wrap="square" anchor="t" lIns="45720" rIns="45720" tIns="27432" bIns="27432">
+          <a:bodyPr wrap="square" lIns="45720" tIns="27432" rIns="45720" bIns="27432" anchor="t">
             <a:spAutoFit/>
           </a:bodyPr>
           <a:lstStyle/>
@@ -6805,6 +6733,7 @@
           <a:lstStyle/>
           <a:p>
             <a:pPr algn="ctr"/>
+            <a:endParaRPr/>
           </a:p>
         </p:txBody>
       </p:sp>
@@ -6825,7 +6754,7 @@
           <a:noFill/>
         </p:spPr>
         <p:txBody>
-          <a:bodyPr wrap="square" anchor="t" lIns="45720" rIns="45720" tIns="27432" bIns="27432">
+          <a:bodyPr wrap="square" lIns="45720" tIns="27432" rIns="45720" bIns="27432" anchor="t">
             <a:spAutoFit/>
           </a:bodyPr>
           <a:lstStyle/>
@@ -6904,6 +6833,7 @@
           <a:lstStyle/>
           <a:p>
             <a:pPr algn="ctr"/>
+            <a:endParaRPr/>
           </a:p>
         </p:txBody>
       </p:sp>
@@ -6948,6 +6878,7 @@
           <a:lstStyle/>
           <a:p>
             <a:pPr algn="ctr"/>
+            <a:endParaRPr/>
           </a:p>
         </p:txBody>
       </p:sp>
@@ -6968,7 +6899,7 @@
           <a:noFill/>
         </p:spPr>
         <p:txBody>
-          <a:bodyPr wrap="square" anchor="t" lIns="45720" rIns="45720" tIns="27432" bIns="27432">
+          <a:bodyPr wrap="square" lIns="45720" tIns="27432" rIns="45720" bIns="27432" anchor="t">
             <a:spAutoFit/>
           </a:bodyPr>
           <a:lstStyle/>
@@ -7047,6 +6978,7 @@
           <a:lstStyle/>
           <a:p>
             <a:pPr algn="ctr"/>
+            <a:endParaRPr/>
           </a:p>
         </p:txBody>
       </p:sp>
@@ -7091,6 +7023,7 @@
           <a:lstStyle/>
           <a:p>
             <a:pPr algn="ctr"/>
+            <a:endParaRPr/>
           </a:p>
         </p:txBody>
       </p:sp>
@@ -7111,7 +7044,7 @@
           <a:noFill/>
         </p:spPr>
         <p:txBody>
-          <a:bodyPr wrap="square" anchor="t" lIns="45720" rIns="45720" tIns="27432" bIns="27432">
+          <a:bodyPr wrap="square" lIns="45720" tIns="27432" rIns="45720" bIns="27432" anchor="t">
             <a:spAutoFit/>
           </a:bodyPr>
           <a:lstStyle/>
@@ -7166,7 +7099,7 @@
           <a:noFill/>
         </p:spPr>
         <p:txBody>
-          <a:bodyPr wrap="square" anchor="t" lIns="45720" rIns="45720" tIns="27432" bIns="27432">
+          <a:bodyPr wrap="square" lIns="45720" tIns="27432" rIns="45720" bIns="27432" anchor="t">
             <a:spAutoFit/>
           </a:bodyPr>
           <a:lstStyle/>
@@ -7221,7 +7154,7 @@
           <a:noFill/>
         </p:spPr>
         <p:txBody>
-          <a:bodyPr wrap="square" anchor="t" lIns="45720" rIns="45720" tIns="27432" bIns="27432">
+          <a:bodyPr wrap="square" lIns="45720" tIns="27432" rIns="45720" bIns="27432" anchor="t">
             <a:spAutoFit/>
           </a:bodyPr>
           <a:lstStyle/>
@@ -7300,6 +7233,7 @@
           <a:lstStyle/>
           <a:p>
             <a:pPr algn="ctr"/>
+            <a:endParaRPr/>
           </a:p>
         </p:txBody>
       </p:sp>
@@ -7320,7 +7254,7 @@
           <a:noFill/>
         </p:spPr>
         <p:txBody>
-          <a:bodyPr wrap="square" anchor="t" lIns="45720" rIns="45720" tIns="27432" bIns="27432">
+          <a:bodyPr wrap="square" lIns="45720" tIns="27432" rIns="45720" bIns="27432" anchor="t">
             <a:spAutoFit/>
           </a:bodyPr>
           <a:lstStyle/>
@@ -7359,7 +7293,7 @@
           <a:noFill/>
         </p:spPr>
         <p:txBody>
-          <a:bodyPr wrap="square" anchor="t" lIns="45720" rIns="45720" tIns="27432" bIns="27432">
+          <a:bodyPr wrap="square" lIns="45720" tIns="27432" rIns="45720" bIns="27432" anchor="t">
             <a:spAutoFit/>
           </a:bodyPr>
           <a:lstStyle/>
@@ -7438,6 +7372,7 @@
           <a:lstStyle/>
           <a:p>
             <a:pPr algn="ctr"/>
+            <a:endParaRPr/>
           </a:p>
         </p:txBody>
       </p:sp>
@@ -7458,7 +7393,7 @@
           <a:noFill/>
         </p:spPr>
         <p:txBody>
-          <a:bodyPr wrap="square" anchor="t" lIns="45720" rIns="45720" tIns="27432" bIns="27432">
+          <a:bodyPr wrap="square" lIns="45720" tIns="27432" rIns="45720" bIns="27432" anchor="t">
             <a:spAutoFit/>
           </a:bodyPr>
           <a:lstStyle/>
@@ -7497,7 +7432,7 @@
           <a:noFill/>
         </p:spPr>
         <p:txBody>
-          <a:bodyPr wrap="square" anchor="t" lIns="45720" rIns="45720" tIns="27432" bIns="27432">
+          <a:bodyPr wrap="square" lIns="45720" tIns="27432" rIns="45720" bIns="27432" anchor="t">
             <a:spAutoFit/>
           </a:bodyPr>
           <a:lstStyle/>
@@ -7576,6 +7511,7 @@
           <a:lstStyle/>
           <a:p>
             <a:pPr algn="ctr"/>
+            <a:endParaRPr/>
           </a:p>
         </p:txBody>
       </p:sp>
@@ -7596,7 +7532,7 @@
           <a:noFill/>
         </p:spPr>
         <p:txBody>
-          <a:bodyPr wrap="square" anchor="t" lIns="45720" rIns="45720" tIns="27432" bIns="27432">
+          <a:bodyPr wrap="square" lIns="45720" tIns="27432" rIns="45720" bIns="27432" anchor="t">
             <a:spAutoFit/>
           </a:bodyPr>
           <a:lstStyle/>
@@ -7635,7 +7571,7 @@
           <a:noFill/>
         </p:spPr>
         <p:txBody>
-          <a:bodyPr wrap="square" anchor="t" lIns="45720" rIns="45720" tIns="27432" bIns="27432">
+          <a:bodyPr wrap="square" lIns="45720" tIns="27432" rIns="45720" bIns="27432" anchor="t">
             <a:spAutoFit/>
           </a:bodyPr>
           <a:lstStyle/>
@@ -7682,7 +7618,7 @@
 </file>
 
 <file path=ppt/slides/slide5.xml><?xml version="1.0" encoding="utf-8"?>
-<p:sld xmlns:a="http://schemas.openxmlformats.org/drawingml/2006/main" xmlns:p="http://schemas.openxmlformats.org/presentationml/2006/main" xmlns:r="http://schemas.openxmlformats.org/officeDocument/2006/relationships">
+<p:sld xmlns:a="http://schemas.openxmlformats.org/drawingml/2006/main" xmlns:r="http://schemas.openxmlformats.org/officeDocument/2006/relationships" xmlns:p="http://schemas.openxmlformats.org/presentationml/2006/main">
   <p:cSld>
     <p:spTree>
       <p:nvGrpSpPr>
@@ -7690,7 +7626,14 @@
         <p:cNvGrpSpPr/>
         <p:nvPr/>
       </p:nvGrpSpPr>
-      <p:grpSpPr/>
+      <p:grpSpPr>
+        <a:xfrm>
+          <a:off x="0" y="0"/>
+          <a:ext cx="0" cy="0"/>
+          <a:chOff x="0" y="0"/>
+          <a:chExt cx="0" cy="0"/>
+        </a:xfrm>
+      </p:grpSpPr>
       <p:sp>
         <p:nvSpPr>
           <p:cNvPr id="2" name="TextBox 1"/>
@@ -7708,7 +7651,7 @@
           <a:noFill/>
         </p:spPr>
         <p:txBody>
-          <a:bodyPr wrap="square" anchor="t" lIns="45720" rIns="45720" tIns="27432" bIns="27432">
+          <a:bodyPr wrap="square" lIns="45720" tIns="27432" rIns="45720" bIns="27432" anchor="t">
             <a:spAutoFit/>
           </a:bodyPr>
           <a:lstStyle/>
@@ -7736,11 +7679,17 @@
           <p:cNvGraphicFramePr>
             <a:graphicFrameLocks noGrp="1"/>
           </p:cNvGraphicFramePr>
-          <p:nvPr/>
+          <p:nvPr>
+            <p:extLst>
+              <p:ext uri="{D42A27DB-BD31-4B8C-83A1-F6EECF244321}">
+                <p14:modId xmlns:p14="http://schemas.microsoft.com/office/powerpoint/2010/main" val="1170979996"/>
+              </p:ext>
+            </p:extLst>
+          </p:nvPr>
         </p:nvGraphicFramePr>
         <p:xfrm>
           <a:off x="548640" y="1234440"/>
-          <a:ext cx="11091672" cy="2926080"/>
+          <a:ext cx="11091672" cy="2535936"/>
         </p:xfrm>
         <a:graphic>
           <a:graphicData uri="http://schemas.openxmlformats.org/drawingml/2006/table">
@@ -7749,9 +7698,27 @@
                 <a:tableStyleId>{5C22544A-7EE6-4342-B048-85BDC9FD1C3A}</a:tableStyleId>
               </a:tblPr>
               <a:tblGrid>
-                <a:gridCol w="2148840"/>
-                <a:gridCol w="4023360"/>
-                <a:gridCol w="4919472"/>
+                <a:gridCol w="2148840">
+                  <a:extLst>
+                    <a:ext uri="{9D8B030D-6E8A-4147-A177-3AD203B41FA5}">
+                      <a16:colId xmlns:a16="http://schemas.microsoft.com/office/drawing/2014/main" val="20000"/>
+                    </a:ext>
+                  </a:extLst>
+                </a:gridCol>
+                <a:gridCol w="4023360">
+                  <a:extLst>
+                    <a:ext uri="{9D8B030D-6E8A-4147-A177-3AD203B41FA5}">
+                      <a16:colId xmlns:a16="http://schemas.microsoft.com/office/drawing/2014/main" val="20001"/>
+                    </a:ext>
+                  </a:extLst>
+                </a:gridCol>
+                <a:gridCol w="4919472">
+                  <a:extLst>
+                    <a:ext uri="{9D8B030D-6E8A-4147-A177-3AD203B41FA5}">
+                      <a16:colId xmlns:a16="http://schemas.microsoft.com/office/drawing/2014/main" val="20002"/>
+                    </a:ext>
+                  </a:extLst>
+                </a:gridCol>
               </a:tblGrid>
               <a:tr h="292608">
                 <a:tc>
@@ -7767,6 +7734,7 @@
                           <a:latin typeface="Calibri"/>
                         </a:defRPr>
                       </a:pPr>
+                      <a:endParaRPr/>
                     </a:p>
                   </a:txBody>
                   <a:tcPr marL="54864" marR="54864" marT="27432" marB="27432">
@@ -7823,6 +7791,11 @@
                     </a:solidFill>
                   </a:tcPr>
                 </a:tc>
+                <a:extLst>
+                  <a:ext uri="{0D108BD9-81ED-4DB2-BD59-A6C34878D82A}">
+                    <a16:rowId xmlns:a16="http://schemas.microsoft.com/office/drawing/2014/main" val="10000"/>
+                  </a:ext>
+                </a:extLst>
               </a:tr>
               <a:tr h="292608">
                 <a:tc>
@@ -7863,7 +7836,8 @@
                         </a:defRPr>
                       </a:pPr>
                       <a:r>
-                        <a:t>an old rule nobody remembers, then four reviewers</a:t>
+                        <a:rPr dirty="0"/>
+                        <a:t>an old rule, then four reviewers</a:t>
                       </a:r>
                     </a:p>
                   </a:txBody>
@@ -7897,6 +7871,11 @@
                     </a:solidFill>
                   </a:tcPr>
                 </a:tc>
+                <a:extLst>
+                  <a:ext uri="{0D108BD9-81ED-4DB2-BD59-A6C34878D82A}">
+                    <a16:rowId xmlns:a16="http://schemas.microsoft.com/office/drawing/2014/main" val="10001"/>
+                  </a:ext>
+                </a:extLst>
               </a:tr>
               <a:tr h="292608">
                 <a:tc>
@@ -7971,6 +7950,11 @@
                     </a:solidFill>
                   </a:tcPr>
                 </a:tc>
+                <a:extLst>
+                  <a:ext uri="{0D108BD9-81ED-4DB2-BD59-A6C34878D82A}">
+                    <a16:rowId xmlns:a16="http://schemas.microsoft.com/office/drawing/2014/main" val="10002"/>
+                  </a:ext>
+                </a:extLst>
               </a:tr>
               <a:tr h="292608">
                 <a:tc>
@@ -8011,6 +7995,7 @@
                         </a:defRPr>
                       </a:pPr>
                       <a:r>
+                        <a:rPr dirty="0"/>
                         <a:t>1,119 minutes over 137 requests</a:t>
                       </a:r>
                     </a:p>
@@ -8045,6 +8030,11 @@
                     </a:solidFill>
                   </a:tcPr>
                 </a:tc>
+                <a:extLst>
+                  <a:ext uri="{0D108BD9-81ED-4DB2-BD59-A6C34878D82A}">
+                    <a16:rowId xmlns:a16="http://schemas.microsoft.com/office/drawing/2014/main" val="10003"/>
+                  </a:ext>
+                </a:extLst>
               </a:tr>
               <a:tr h="292608">
                 <a:tc>
@@ -8085,6 +8075,7 @@
                         </a:defRPr>
                       </a:pPr>
                       <a:r>
+                        <a:rPr dirty="0"/>
                         <a:t>not recorded</a:t>
                       </a:r>
                     </a:p>
@@ -8119,6 +8110,11 @@
                     </a:solidFill>
                   </a:tcPr>
                 </a:tc>
+                <a:extLst>
+                  <a:ext uri="{0D108BD9-81ED-4DB2-BD59-A6C34878D82A}">
+                    <a16:rowId xmlns:a16="http://schemas.microsoft.com/office/drawing/2014/main" val="10004"/>
+                  </a:ext>
+                </a:extLst>
               </a:tr>
               <a:tr h="292608">
                 <a:tc>
@@ -8193,6 +8189,11 @@
                     </a:solidFill>
                   </a:tcPr>
                 </a:tc>
+                <a:extLst>
+                  <a:ext uri="{0D108BD9-81ED-4DB2-BD59-A6C34878D82A}">
+                    <a16:rowId xmlns:a16="http://schemas.microsoft.com/office/drawing/2014/main" val="10005"/>
+                  </a:ext>
+                </a:extLst>
               </a:tr>
               <a:tr h="292608">
                 <a:tc>
@@ -8267,154 +8268,11 @@
                     </a:solidFill>
                   </a:tcPr>
                 </a:tc>
-              </a:tr>
-              <a:tr h="292608">
-                <a:tc>
-                  <a:txBody>
-                    <a:bodyPr/>
-                    <a:lstStyle/>
-                    <a:p>
-                      <a:pPr>
-                        <a:defRPr sz="1100" b="0">
-                          <a:solidFill>
-                            <a:srgbClr val="1B1B1B"/>
-                          </a:solidFill>
-                          <a:latin typeface="Calibri"/>
-                        </a:defRPr>
-                      </a:pPr>
-                      <a:r>
-                        <a:t>changing a rule</a:t>
-                      </a:r>
-                    </a:p>
-                  </a:txBody>
-                  <a:tcPr marL="54864" marR="54864" marT="27432" marB="27432">
-                    <a:solidFill>
-                      <a:srgbClr val="F1EDE4"/>
-                    </a:solidFill>
-                  </a:tcPr>
-                </a:tc>
-                <a:tc>
-                  <a:txBody>
-                    <a:bodyPr/>
-                    <a:lstStyle/>
-                    <a:p>
-                      <a:pPr>
-                        <a:defRPr sz="1100" b="0">
-                          <a:solidFill>
-                            <a:srgbClr val="1B1B1B"/>
-                          </a:solidFill>
-                          <a:latin typeface="Calibri"/>
-                        </a:defRPr>
-                      </a:pPr>
-                      <a:r>
-                        <a:t>find whoever set it up at IT; no way to test it first</a:t>
-                      </a:r>
-                    </a:p>
-                  </a:txBody>
-                  <a:tcPr marL="54864" marR="54864" marT="27432" marB="27432">
-                    <a:solidFill>
-                      <a:srgbClr val="F1EDE4"/>
-                    </a:solidFill>
-                  </a:tcPr>
-                </a:tc>
-                <a:tc>
-                  <a:txBody>
-                    <a:bodyPr/>
-                    <a:lstStyle/>
-                    <a:p>
-                      <a:pPr>
-                        <a:defRPr sz="1100" b="0">
-                          <a:solidFill>
-                            <a:srgbClr val="1B1B1B"/>
-                          </a:solidFill>
-                          <a:latin typeface="Calibri"/>
-                        </a:defRPr>
-                      </a:pPr>
-                      <a:r>
-                        <a:t>the manager types a sentence, sees the dry run on 248 past cases, publishes a version; rollback in one click</a:t>
-                      </a:r>
-                    </a:p>
-                  </a:txBody>
-                  <a:tcPr marL="54864" marR="54864" marT="27432" marB="27432">
-                    <a:solidFill>
-                      <a:srgbClr val="F1EDE4"/>
-                    </a:solidFill>
-                  </a:tcPr>
-                </a:tc>
-              </a:tr>
-              <a:tr h="292608">
-                <a:tc>
-                  <a:txBody>
-                    <a:bodyPr/>
-                    <a:lstStyle/>
-                    <a:p>
-                      <a:pPr>
-                        <a:defRPr sz="1100" b="0">
-                          <a:solidFill>
-                            <a:srgbClr val="1B1B1B"/>
-                          </a:solidFill>
-                          <a:latin typeface="Calibri"/>
-                        </a:defRPr>
-                      </a:pPr>
-                      <a:r>
-                        <a:t>catching a bad rule</a:t>
-                      </a:r>
-                    </a:p>
-                  </a:txBody>
-                  <a:tcPr marL="54864" marR="54864" marT="27432" marB="27432">
-                    <a:solidFill>
-                      <a:srgbClr val="FFFFFF"/>
-                    </a:solidFill>
-                  </a:tcPr>
-                </a:tc>
-                <a:tc>
-                  <a:txBody>
-                    <a:bodyPr/>
-                    <a:lstStyle/>
-                    <a:p>
-                      <a:pPr>
-                        <a:defRPr sz="1100" b="0">
-                          <a:solidFill>
-                            <a:srgbClr val="1B1B1B"/>
-                          </a:solidFill>
-                          <a:latin typeface="Calibri"/>
-                        </a:defRPr>
-                      </a:pPr>
-                      <a:r>
-                        <a:t>a chargeback, weeks later</a:t>
-                      </a:r>
-                    </a:p>
-                  </a:txBody>
-                  <a:tcPr marL="54864" marR="54864" marT="27432" marB="27432">
-                    <a:solidFill>
-                      <a:srgbClr val="FFFFFF"/>
-                    </a:solidFill>
-                  </a:tcPr>
-                </a:tc>
-                <a:tc>
-                  <a:txBody>
-                    <a:bodyPr/>
-                    <a:lstStyle/>
-                    <a:p>
-                      <a:pPr>
-                        <a:defRPr sz="1100" b="0">
-                          <a:solidFill>
-                            <a:srgbClr val="1B1B1B"/>
-                          </a:solidFill>
-                          <a:latin typeface="Calibri"/>
-                        </a:defRPr>
-                      </a:pPr>
-                      <a:r>
-                        <a:t>the replay before publishing; five weekly numbers and two rollback levels after</a:t>
-                      </a:r>
-                    </a:p>
-                  </a:txBody>
-                  <a:tcPr marL="54864" marR="54864" marT="27432" marB="27432">
-                    <a:solidFill>
-                      <a:srgbClr val="FFFFFF"/>
-                    </a:solidFill>
-                  </a:tcPr>
-                </a:tc>
+                <a:extLst>
+                  <a:ext uri="{0D108BD9-81ED-4DB2-BD59-A6C34878D82A}">
+                    <a16:rowId xmlns:a16="http://schemas.microsoft.com/office/drawing/2014/main" val="10006"/>
+                  </a:ext>
+                </a:extLst>
               </a:tr>
               <a:tr h="292608">
                 <a:tc>
@@ -8479,6 +8337,7 @@
                         </a:defRPr>
                       </a:pPr>
                       <a:r>
+                        <a:rPr dirty="0"/>
                         <a:t>unchanged: the system never rejects</a:t>
                       </a:r>
                     </a:p>
@@ -8489,6 +8348,11 @@
                     </a:solidFill>
                   </a:tcPr>
                 </a:tc>
+                <a:extLst>
+                  <a:ext uri="{0D108BD9-81ED-4DB2-BD59-A6C34878D82A}">
+                    <a16:rowId xmlns:a16="http://schemas.microsoft.com/office/drawing/2014/main" val="10009"/>
+                  </a:ext>
+                </a:extLst>
               </a:tr>
             </a:tbl>
           </a:graphicData>
@@ -8535,6 +8399,7 @@
           <a:lstStyle/>
           <a:p>
             <a:pPr algn="ctr"/>
+            <a:endParaRPr/>
           </a:p>
         </p:txBody>
       </p:sp>
@@ -8555,7 +8420,7 @@
           <a:noFill/>
         </p:spPr>
         <p:txBody>
-          <a:bodyPr wrap="square" anchor="t" lIns="45720" rIns="45720" tIns="27432" bIns="27432">
+          <a:bodyPr wrap="square" lIns="45720" tIns="27432" rIns="45720" bIns="27432" anchor="t">
             <a:spAutoFit/>
           </a:bodyPr>
           <a:lstStyle/>
@@ -8594,7 +8459,7 @@
           <a:noFill/>
         </p:spPr>
         <p:txBody>
-          <a:bodyPr wrap="square" anchor="t" lIns="45720" rIns="45720" tIns="27432" bIns="27432">
+          <a:bodyPr wrap="square" lIns="45720" tIns="27432" rIns="45720" bIns="27432" anchor="t">
             <a:spAutoFit/>
           </a:bodyPr>
           <a:lstStyle/>
@@ -8657,6 +8522,7 @@
           <a:lstStyle/>
           <a:p>
             <a:pPr algn="ctr"/>
+            <a:endParaRPr/>
           </a:p>
         </p:txBody>
       </p:sp>
@@ -8668,7 +8534,7 @@
         </p:nvSpPr>
         <p:spPr>
           <a:xfrm>
-            <a:off x="4505858" y="5074920"/>
+            <a:off x="4505858" y="5102352"/>
             <a:ext cx="3179978" cy="594360"/>
           </a:xfrm>
           <a:prstGeom prst="rect">
@@ -8677,7 +8543,7 @@
           <a:noFill/>
         </p:spPr>
         <p:txBody>
-          <a:bodyPr wrap="square" anchor="t" lIns="45720" rIns="45720" tIns="27432" bIns="27432">
+          <a:bodyPr wrap="square" lIns="45720" tIns="27432" rIns="45720" bIns="27432" anchor="t">
             <a:spAutoFit/>
           </a:bodyPr>
           <a:lstStyle/>
@@ -8716,7 +8582,7 @@
           <a:noFill/>
         </p:spPr>
         <p:txBody>
-          <a:bodyPr wrap="square" anchor="t" lIns="45720" rIns="45720" tIns="27432" bIns="27432">
+          <a:bodyPr wrap="square" lIns="45720" tIns="27432" rIns="45720" bIns="27432" anchor="t">
             <a:spAutoFit/>
           </a:bodyPr>
           <a:lstStyle/>
@@ -8779,6 +8645,7 @@
           <a:lstStyle/>
           <a:p>
             <a:pPr algn="ctr"/>
+            <a:endParaRPr/>
           </a:p>
         </p:txBody>
       </p:sp>
@@ -8799,7 +8666,7 @@
           <a:noFill/>
         </p:spPr>
         <p:txBody>
-          <a:bodyPr wrap="square" anchor="t" lIns="45720" rIns="45720" tIns="27432" bIns="27432">
+          <a:bodyPr wrap="square" lIns="45720" tIns="27432" rIns="45720" bIns="27432" anchor="t">
             <a:spAutoFit/>
           </a:bodyPr>
           <a:lstStyle/>
@@ -8838,7 +8705,7 @@
           <a:noFill/>
         </p:spPr>
         <p:txBody>
-          <a:bodyPr wrap="square" anchor="t" lIns="45720" rIns="45720" tIns="27432" bIns="27432">
+          <a:bodyPr wrap="square" lIns="45720" tIns="27432" rIns="45720" bIns="27432" anchor="t">
             <a:spAutoFit/>
           </a:bodyPr>
           <a:lstStyle/>
@@ -8869,7 +8736,7 @@
 </file>
 
 <file path=ppt/slides/slide6.xml><?xml version="1.0" encoding="utf-8"?>
-<p:sld xmlns:a="http://schemas.openxmlformats.org/drawingml/2006/main" xmlns:p="http://schemas.openxmlformats.org/presentationml/2006/main" xmlns:r="http://schemas.openxmlformats.org/officeDocument/2006/relationships">
+<p:sld xmlns:a="http://schemas.openxmlformats.org/drawingml/2006/main" xmlns:r="http://schemas.openxmlformats.org/officeDocument/2006/relationships" xmlns:p="http://schemas.openxmlformats.org/presentationml/2006/main">
   <p:cSld>
     <p:spTree>
       <p:nvGrpSpPr>
@@ -8877,7 +8744,14 @@
         <p:cNvGrpSpPr/>
         <p:nvPr/>
       </p:nvGrpSpPr>
-      <p:grpSpPr/>
+      <p:grpSpPr>
+        <a:xfrm>
+          <a:off x="0" y="0"/>
+          <a:ext cx="0" cy="0"/>
+          <a:chOff x="0" y="0"/>
+          <a:chExt cx="0" cy="0"/>
+        </a:xfrm>
+      </p:grpSpPr>
       <p:sp>
         <p:nvSpPr>
           <p:cNvPr id="2" name="TextBox 1"/>
@@ -8895,7 +8769,7 @@
           <a:noFill/>
         </p:spPr>
         <p:txBody>
-          <a:bodyPr wrap="square" anchor="t" lIns="45720" rIns="45720" tIns="27432" bIns="27432">
+          <a:bodyPr wrap="square" lIns="45720" tIns="27432" rIns="45720" bIns="27432" anchor="t">
             <a:spAutoFit/>
           </a:bodyPr>
           <a:lstStyle/>
@@ -8958,6 +8832,7 @@
           <a:lstStyle/>
           <a:p>
             <a:pPr algn="ctr"/>
+            <a:endParaRPr/>
           </a:p>
         </p:txBody>
       </p:sp>
@@ -8978,7 +8853,7 @@
           <a:noFill/>
         </p:spPr>
         <p:txBody>
-          <a:bodyPr wrap="square" anchor="t" lIns="45720" rIns="45720" tIns="27432" bIns="27432">
+          <a:bodyPr wrap="square" lIns="45720" tIns="27432" rIns="45720" bIns="27432" anchor="t">
             <a:spAutoFit/>
           </a:bodyPr>
           <a:lstStyle/>
@@ -9017,7 +8892,7 @@
           <a:noFill/>
         </p:spPr>
         <p:txBody>
-          <a:bodyPr wrap="square" anchor="t" lIns="45720" rIns="45720" tIns="27432" bIns="27432">
+          <a:bodyPr wrap="square" lIns="45720" tIns="27432" rIns="45720" bIns="27432" anchor="t">
             <a:spAutoFit/>
           </a:bodyPr>
           <a:lstStyle/>
@@ -9096,6 +8971,7 @@
           <a:lstStyle/>
           <a:p>
             <a:pPr algn="ctr"/>
+            <a:endParaRPr/>
           </a:p>
         </p:txBody>
       </p:sp>
@@ -9116,7 +8992,7 @@
           <a:noFill/>
         </p:spPr>
         <p:txBody>
-          <a:bodyPr wrap="square" anchor="t" lIns="45720" rIns="45720" tIns="27432" bIns="27432">
+          <a:bodyPr wrap="square" lIns="45720" tIns="27432" rIns="45720" bIns="27432" anchor="t">
             <a:spAutoFit/>
           </a:bodyPr>
           <a:lstStyle/>
@@ -9155,7 +9031,7 @@
           <a:noFill/>
         </p:spPr>
         <p:txBody>
-          <a:bodyPr wrap="square" anchor="t" lIns="45720" rIns="45720" tIns="27432" bIns="27432">
+          <a:bodyPr wrap="square" lIns="45720" tIns="27432" rIns="45720" bIns="27432" anchor="t">
             <a:spAutoFit/>
           </a:bodyPr>
           <a:lstStyle/>
@@ -9210,7 +9086,7 @@
           <a:noFill/>
         </p:spPr>
         <p:txBody>
-          <a:bodyPr wrap="square" anchor="t" lIns="45720" rIns="45720" tIns="27432" bIns="27432">
+          <a:bodyPr wrap="square" lIns="45720" tIns="27432" rIns="45720" bIns="27432" anchor="t">
             <a:spAutoFit/>
           </a:bodyPr>
           <a:lstStyle/>
@@ -9251,8 +9127,20 @@
                 <a:tableStyleId>{5C22544A-7EE6-4342-B048-85BDC9FD1C3A}</a:tableStyleId>
               </a:tblPr>
               <a:tblGrid>
-                <a:gridCol w="2834640"/>
-                <a:gridCol w="2606040"/>
+                <a:gridCol w="2834640">
+                  <a:extLst>
+                    <a:ext uri="{9D8B030D-6E8A-4147-A177-3AD203B41FA5}">
+                      <a16:colId xmlns:a16="http://schemas.microsoft.com/office/drawing/2014/main" val="20000"/>
+                    </a:ext>
+                  </a:extLst>
+                </a:gridCol>
+                <a:gridCol w="2606040">
+                  <a:extLst>
+                    <a:ext uri="{9D8B030D-6E8A-4147-A177-3AD203B41FA5}">
+                      <a16:colId xmlns:a16="http://schemas.microsoft.com/office/drawing/2014/main" val="20001"/>
+                    </a:ext>
+                  </a:extLst>
+                </a:gridCol>
               </a:tblGrid>
               <a:tr h="292608">
                 <a:tc>
@@ -9303,6 +9191,11 @@
                     </a:solidFill>
                   </a:tcPr>
                 </a:tc>
+                <a:extLst>
+                  <a:ext uri="{0D108BD9-81ED-4DB2-BD59-A6C34878D82A}">
+                    <a16:rowId xmlns:a16="http://schemas.microsoft.com/office/drawing/2014/main" val="10000"/>
+                  </a:ext>
+                </a:extLst>
               </a:tr>
               <a:tr h="292608">
                 <a:tc>
@@ -9353,6 +9246,11 @@
                     </a:solidFill>
                   </a:tcPr>
                 </a:tc>
+                <a:extLst>
+                  <a:ext uri="{0D108BD9-81ED-4DB2-BD59-A6C34878D82A}">
+                    <a16:rowId xmlns:a16="http://schemas.microsoft.com/office/drawing/2014/main" val="10001"/>
+                  </a:ext>
+                </a:extLst>
               </a:tr>
               <a:tr h="292608">
                 <a:tc>
@@ -9403,6 +9301,11 @@
                     </a:solidFill>
                   </a:tcPr>
                 </a:tc>
+                <a:extLst>
+                  <a:ext uri="{0D108BD9-81ED-4DB2-BD59-A6C34878D82A}">
+                    <a16:rowId xmlns:a16="http://schemas.microsoft.com/office/drawing/2014/main" val="10002"/>
+                  </a:ext>
+                </a:extLst>
               </a:tr>
               <a:tr h="292608">
                 <a:tc>
@@ -9453,6 +9356,11 @@
                     </a:solidFill>
                   </a:tcPr>
                 </a:tc>
+                <a:extLst>
+                  <a:ext uri="{0D108BD9-81ED-4DB2-BD59-A6C34878D82A}">
+                    <a16:rowId xmlns:a16="http://schemas.microsoft.com/office/drawing/2014/main" val="10003"/>
+                  </a:ext>
+                </a:extLst>
               </a:tr>
               <a:tr h="292608">
                 <a:tc>
@@ -9503,6 +9411,11 @@
                     </a:solidFill>
                   </a:tcPr>
                 </a:tc>
+                <a:extLst>
+                  <a:ext uri="{0D108BD9-81ED-4DB2-BD59-A6C34878D82A}">
+                    <a16:rowId xmlns:a16="http://schemas.microsoft.com/office/drawing/2014/main" val="10004"/>
+                  </a:ext>
+                </a:extLst>
               </a:tr>
               <a:tr h="292608">
                 <a:tc>
@@ -9553,6 +9466,11 @@
                     </a:solidFill>
                   </a:tcPr>
                 </a:tc>
+                <a:extLst>
+                  <a:ext uri="{0D108BD9-81ED-4DB2-BD59-A6C34878D82A}">
+                    <a16:rowId xmlns:a16="http://schemas.microsoft.com/office/drawing/2014/main" val="10005"/>
+                  </a:ext>
+                </a:extLst>
               </a:tr>
             </a:tbl>
           </a:graphicData>
@@ -9575,7 +9493,7 @@
           <a:noFill/>
         </p:spPr>
         <p:txBody>
-          <a:bodyPr wrap="square" anchor="t" lIns="45720" rIns="45720" tIns="27432" bIns="27432">
+          <a:bodyPr wrap="square" lIns="45720" tIns="27432" rIns="45720" bIns="27432" anchor="t">
             <a:spAutoFit/>
           </a:bodyPr>
           <a:lstStyle/>
@@ -9606,7 +9524,7 @@
 </file>
 
 <file path=ppt/slides/slide7.xml><?xml version="1.0" encoding="utf-8"?>
-<p:sld xmlns:a="http://schemas.openxmlformats.org/drawingml/2006/main" xmlns:p="http://schemas.openxmlformats.org/presentationml/2006/main" xmlns:r="http://schemas.openxmlformats.org/officeDocument/2006/relationships">
+<p:sld xmlns:a="http://schemas.openxmlformats.org/drawingml/2006/main" xmlns:r="http://schemas.openxmlformats.org/officeDocument/2006/relationships" xmlns:p="http://schemas.openxmlformats.org/presentationml/2006/main">
   <p:cSld>
     <p:spTree>
       <p:nvGrpSpPr>
@@ -9614,7 +9532,14 @@
         <p:cNvGrpSpPr/>
         <p:nvPr/>
       </p:nvGrpSpPr>
-      <p:grpSpPr/>
+      <p:grpSpPr>
+        <a:xfrm>
+          <a:off x="0" y="0"/>
+          <a:ext cx="0" cy="0"/>
+          <a:chOff x="0" y="0"/>
+          <a:chExt cx="0" cy="0"/>
+        </a:xfrm>
+      </p:grpSpPr>
       <p:sp>
         <p:nvSpPr>
           <p:cNvPr id="2" name="TextBox 1"/>
@@ -9632,7 +9557,7 @@
           <a:noFill/>
         </p:spPr>
         <p:txBody>
-          <a:bodyPr wrap="square" anchor="t" lIns="45720" rIns="45720" tIns="27432" bIns="27432">
+          <a:bodyPr wrap="square" lIns="45720" tIns="27432" rIns="45720" bIns="27432" anchor="t">
             <a:spAutoFit/>
           </a:bodyPr>
           <a:lstStyle/>
@@ -9695,6 +9620,7 @@
           <a:lstStyle/>
           <a:p>
             <a:pPr algn="ctr"/>
+            <a:endParaRPr/>
           </a:p>
         </p:txBody>
       </p:sp>
@@ -9715,7 +9641,7 @@
           <a:noFill/>
         </p:spPr>
         <p:txBody>
-          <a:bodyPr wrap="square" anchor="t" lIns="45720" rIns="45720" tIns="27432" bIns="27432">
+          <a:bodyPr wrap="square" lIns="45720" tIns="27432" rIns="45720" bIns="27432" anchor="t">
             <a:spAutoFit/>
           </a:bodyPr>
           <a:lstStyle/>
@@ -9754,7 +9680,7 @@
           <a:noFill/>
         </p:spPr>
         <p:txBody>
-          <a:bodyPr wrap="square" anchor="t" lIns="45720" rIns="45720" tIns="27432" bIns="27432">
+          <a:bodyPr wrap="square" lIns="45720" tIns="27432" rIns="45720" bIns="27432" anchor="t">
             <a:spAutoFit/>
           </a:bodyPr>
           <a:lstStyle/>
@@ -9801,7 +9727,7 @@
         <p:spPr>
           <a:xfrm>
             <a:off x="548640" y="3886200"/>
-            <a:ext cx="5440680" cy="2468880"/>
+            <a:ext cx="5440680" cy="1853184"/>
           </a:xfrm>
           <a:prstGeom prst="roundRect">
             <a:avLst/>
@@ -9833,6 +9759,7 @@
           <a:lstStyle/>
           <a:p>
             <a:pPr algn="ctr"/>
+            <a:endParaRPr/>
           </a:p>
         </p:txBody>
       </p:sp>
@@ -9853,7 +9780,7 @@
           <a:noFill/>
         </p:spPr>
         <p:txBody>
-          <a:bodyPr wrap="square" anchor="t" lIns="45720" rIns="45720" tIns="27432" bIns="27432">
+          <a:bodyPr wrap="square" lIns="45720" tIns="27432" rIns="45720" bIns="27432" anchor="t">
             <a:spAutoFit/>
           </a:bodyPr>
           <a:lstStyle/>
@@ -9884,7 +9811,7 @@
         <p:spPr>
           <a:xfrm>
             <a:off x="777240" y="4526280"/>
-            <a:ext cx="4983480" cy="1691640"/>
+            <a:ext cx="4983480" cy="711990"/>
           </a:xfrm>
           <a:prstGeom prst="rect">
             <a:avLst/>
@@ -9892,7 +9819,7 @@
           <a:noFill/>
         </p:spPr>
         <p:txBody>
-          <a:bodyPr wrap="square" anchor="t" lIns="45720" rIns="45720" tIns="27432" bIns="27432">
+          <a:bodyPr wrap="square" lIns="45720" tIns="27432" rIns="45720" bIns="27432" anchor="t">
             <a:spAutoFit/>
           </a:bodyPr>
           <a:lstStyle/>
@@ -9903,7 +9830,7 @@
               </a:spcAft>
             </a:pPr>
             <a:r>
-              <a:rPr sz="1200" b="0">
+              <a:rPr sz="1200" b="0" dirty="0">
                 <a:solidFill>
                   <a:srgbClr val="1B1B1B"/>
                 </a:solidFill>
@@ -9919,29 +9846,13 @@
               </a:spcAft>
             </a:pPr>
             <a:r>
-              <a:rPr sz="1200" b="0">
+              <a:rPr sz="1200" b="0" dirty="0">
                 <a:solidFill>
                   <a:srgbClr val="1B1B1B"/>
                 </a:solidFill>
                 <a:latin typeface="Calibri"/>
               </a:rPr>
               <a:t>•  Rejecting anyone. Rejections stay with people.</a:t>
-            </a:r>
-          </a:p>
-          <a:p>
-            <a:pPr algn="l">
-              <a:spcAft>
-                <a:spcPts val="800"/>
-              </a:spcAft>
-            </a:pPr>
-            <a:r>
-              <a:rPr sz="1200" b="0">
-                <a:solidFill>
-                  <a:srgbClr val="1B1B1B"/>
-                </a:solidFill>
-                <a:latin typeface="Calibri"/>
-              </a:rPr>
-              <a:t>•  A 'risk score' model: 248 rows is too few, and a line you can explain is worth more.</a:t>
             </a:r>
           </a:p>
         </p:txBody>
@@ -9963,7 +9874,7 @@
           <a:noFill/>
         </p:spPr>
         <p:txBody>
-          <a:bodyPr wrap="square" anchor="t" lIns="45720" rIns="45720" tIns="27432" bIns="27432">
+          <a:bodyPr wrap="square" lIns="45720" tIns="27432" rIns="45720" bIns="27432" anchor="t">
             <a:spAutoFit/>
           </a:bodyPr>
           <a:lstStyle/>
@@ -10002,7 +9913,7 @@
           <a:noFill/>
         </p:spPr>
         <p:txBody>
-          <a:bodyPr wrap="square" anchor="t" lIns="45720" rIns="45720" tIns="27432" bIns="27432">
+          <a:bodyPr wrap="square" lIns="45720" tIns="27432" rIns="45720" bIns="27432" anchor="t">
             <a:spAutoFit/>
           </a:bodyPr>
           <a:lstStyle/>
@@ -10050,7 +9961,7 @@
         </p:nvGraphicFramePr>
         <p:xfrm>
           <a:off x="6217920" y="3520440"/>
-          <a:ext cx="5440680" cy="1755648"/>
+          <a:ext cx="5440680" cy="1853184"/>
         </p:xfrm>
         <a:graphic>
           <a:graphicData uri="http://schemas.openxmlformats.org/drawingml/2006/table">
@@ -10059,9 +9970,27 @@
                 <a:tableStyleId>{5C22544A-7EE6-4342-B048-85BDC9FD1C3A}</a:tableStyleId>
               </a:tblPr>
               <a:tblGrid>
-                <a:gridCol w="2514600"/>
-                <a:gridCol w="1600200"/>
-                <a:gridCol w="1325880"/>
+                <a:gridCol w="2514600">
+                  <a:extLst>
+                    <a:ext uri="{9D8B030D-6E8A-4147-A177-3AD203B41FA5}">
+                      <a16:colId xmlns:a16="http://schemas.microsoft.com/office/drawing/2014/main" val="20000"/>
+                    </a:ext>
+                  </a:extLst>
+                </a:gridCol>
+                <a:gridCol w="1600200">
+                  <a:extLst>
+                    <a:ext uri="{9D8B030D-6E8A-4147-A177-3AD203B41FA5}">
+                      <a16:colId xmlns:a16="http://schemas.microsoft.com/office/drawing/2014/main" val="20001"/>
+                    </a:ext>
+                  </a:extLst>
+                </a:gridCol>
+                <a:gridCol w="1325880">
+                  <a:extLst>
+                    <a:ext uri="{9D8B030D-6E8A-4147-A177-3AD203B41FA5}">
+                      <a16:colId xmlns:a16="http://schemas.microsoft.com/office/drawing/2014/main" val="20002"/>
+                    </a:ext>
+                  </a:extLst>
+                </a:gridCol>
               </a:tblGrid>
               <a:tr h="292608">
                 <a:tc>
@@ -10136,6 +10065,11 @@
                     </a:solidFill>
                   </a:tcPr>
                 </a:tc>
+                <a:extLst>
+                  <a:ext uri="{0D108BD9-81ED-4DB2-BD59-A6C34878D82A}">
+                    <a16:rowId xmlns:a16="http://schemas.microsoft.com/office/drawing/2014/main" val="10000"/>
+                  </a:ext>
+                </a:extLst>
               </a:tr>
               <a:tr h="292608">
                 <a:tc>
@@ -10210,6 +10144,11 @@
                     </a:solidFill>
                   </a:tcPr>
                 </a:tc>
+                <a:extLst>
+                  <a:ext uri="{0D108BD9-81ED-4DB2-BD59-A6C34878D82A}">
+                    <a16:rowId xmlns:a16="http://schemas.microsoft.com/office/drawing/2014/main" val="10001"/>
+                  </a:ext>
+                </a:extLst>
               </a:tr>
               <a:tr h="292608">
                 <a:tc>
@@ -10284,6 +10223,11 @@
                     </a:solidFill>
                   </a:tcPr>
                 </a:tc>
+                <a:extLst>
+                  <a:ext uri="{0D108BD9-81ED-4DB2-BD59-A6C34878D82A}">
+                    <a16:rowId xmlns:a16="http://schemas.microsoft.com/office/drawing/2014/main" val="10002"/>
+                  </a:ext>
+                </a:extLst>
               </a:tr>
               <a:tr h="292608">
                 <a:tc>
@@ -10358,6 +10302,11 @@
                     </a:solidFill>
                   </a:tcPr>
                 </a:tc>
+                <a:extLst>
+                  <a:ext uri="{0D108BD9-81ED-4DB2-BD59-A6C34878D82A}">
+                    <a16:rowId xmlns:a16="http://schemas.microsoft.com/office/drawing/2014/main" val="10003"/>
+                  </a:ext>
+                </a:extLst>
               </a:tr>
               <a:tr h="292608">
                 <a:tc>
@@ -10432,6 +10381,11 @@
                     </a:solidFill>
                   </a:tcPr>
                 </a:tc>
+                <a:extLst>
+                  <a:ext uri="{0D108BD9-81ED-4DB2-BD59-A6C34878D82A}">
+                    <a16:rowId xmlns:a16="http://schemas.microsoft.com/office/drawing/2014/main" val="10004"/>
+                  </a:ext>
+                </a:extLst>
               </a:tr>
               <a:tr h="292608">
                 <a:tc>
@@ -10506,6 +10460,11 @@
                     </a:solidFill>
                   </a:tcPr>
                 </a:tc>
+                <a:extLst>
+                  <a:ext uri="{0D108BD9-81ED-4DB2-BD59-A6C34878D82A}">
+                    <a16:rowId xmlns:a16="http://schemas.microsoft.com/office/drawing/2014/main" val="10005"/>
+                  </a:ext>
+                </a:extLst>
               </a:tr>
             </a:tbl>
           </a:graphicData>
@@ -10528,7 +10487,7 @@
           <a:noFill/>
         </p:spPr>
         <p:txBody>
-          <a:bodyPr wrap="square" anchor="t" lIns="45720" rIns="45720" tIns="27432" bIns="27432">
+          <a:bodyPr wrap="square" lIns="45720" tIns="27432" rIns="45720" bIns="27432" anchor="t">
             <a:spAutoFit/>
           </a:bodyPr>
           <a:lstStyle/>
@@ -10559,7 +10518,7 @@
 </file>
 
 <file path=ppt/slides/slide8.xml><?xml version="1.0" encoding="utf-8"?>
-<p:sld xmlns:a="http://schemas.openxmlformats.org/drawingml/2006/main" xmlns:p="http://schemas.openxmlformats.org/presentationml/2006/main" xmlns:r="http://schemas.openxmlformats.org/officeDocument/2006/relationships">
+<p:sld xmlns:a="http://schemas.openxmlformats.org/drawingml/2006/main" xmlns:r="http://schemas.openxmlformats.org/officeDocument/2006/relationships" xmlns:p="http://schemas.openxmlformats.org/presentationml/2006/main">
   <p:cSld>
     <p:spTree>
       <p:nvGrpSpPr>
@@ -10567,7 +10526,14 @@
         <p:cNvGrpSpPr/>
         <p:nvPr/>
       </p:nvGrpSpPr>
-      <p:grpSpPr/>
+      <p:grpSpPr>
+        <a:xfrm>
+          <a:off x="0" y="0"/>
+          <a:ext cx="0" cy="0"/>
+          <a:chOff x="0" y="0"/>
+          <a:chExt cx="0" cy="0"/>
+        </a:xfrm>
+      </p:grpSpPr>
       <p:sp>
         <p:nvSpPr>
           <p:cNvPr id="2" name="TextBox 1"/>
@@ -10585,7 +10551,7 @@
           <a:noFill/>
         </p:spPr>
         <p:txBody>
-          <a:bodyPr wrap="square" anchor="t" lIns="45720" rIns="45720" tIns="27432" bIns="27432">
+          <a:bodyPr wrap="square" lIns="45720" tIns="27432" rIns="45720" bIns="27432" anchor="t">
             <a:spAutoFit/>
           </a:bodyPr>
           <a:lstStyle/>
@@ -10648,6 +10614,7 @@
           <a:lstStyle/>
           <a:p>
             <a:pPr algn="ctr"/>
+            <a:endParaRPr/>
           </a:p>
         </p:txBody>
       </p:sp>
@@ -10668,7 +10635,7 @@
           <a:noFill/>
         </p:spPr>
         <p:txBody>
-          <a:bodyPr wrap="square" anchor="t" lIns="45720" rIns="45720" tIns="27432" bIns="27432">
+          <a:bodyPr wrap="square" lIns="45720" tIns="27432" rIns="45720" bIns="27432" anchor="t">
             <a:spAutoFit/>
           </a:bodyPr>
           <a:lstStyle/>
@@ -10707,7 +10674,7 @@
           <a:noFill/>
         </p:spPr>
         <p:txBody>
-          <a:bodyPr wrap="square" anchor="t" lIns="45720" rIns="45720" tIns="27432" bIns="27432">
+          <a:bodyPr wrap="square" lIns="45720" tIns="27432" rIns="45720" bIns="27432" anchor="t">
             <a:spAutoFit/>
           </a:bodyPr>
           <a:lstStyle/>
@@ -10802,6 +10769,7 @@
           <a:lstStyle/>
           <a:p>
             <a:pPr algn="ctr"/>
+            <a:endParaRPr/>
           </a:p>
         </p:txBody>
       </p:sp>
@@ -10822,7 +10790,7 @@
           <a:noFill/>
         </p:spPr>
         <p:txBody>
-          <a:bodyPr wrap="square" anchor="t" lIns="45720" rIns="45720" tIns="27432" bIns="27432">
+          <a:bodyPr wrap="square" lIns="45720" tIns="27432" rIns="45720" bIns="27432" anchor="t">
             <a:spAutoFit/>
           </a:bodyPr>
           <a:lstStyle/>
@@ -10861,7 +10829,7 @@
           <a:noFill/>
         </p:spPr>
         <p:txBody>
-          <a:bodyPr wrap="square" anchor="t" lIns="45720" rIns="45720" tIns="27432" bIns="27432">
+          <a:bodyPr wrap="square" lIns="45720" tIns="27432" rIns="45720" bIns="27432" anchor="t">
             <a:spAutoFit/>
           </a:bodyPr>
           <a:lstStyle/>
@@ -11286,44 +11254,44 @@
         <a:sysClr val="window" lastClr="FFFFFF"/>
       </a:lt1>
       <a:dk2>
-        <a:srgbClr val="1F497D"/>
+        <a:srgbClr val="0E2841"/>
       </a:dk2>
       <a:lt2>
-        <a:srgbClr val="EEECE1"/>
+        <a:srgbClr val="E8E8E8"/>
       </a:lt2>
       <a:accent1>
-        <a:srgbClr val="4F81BD"/>
+        <a:srgbClr val="156082"/>
       </a:accent1>
       <a:accent2>
-        <a:srgbClr val="C0504D"/>
+        <a:srgbClr val="E97132"/>
       </a:accent2>
       <a:accent3>
-        <a:srgbClr val="9BBB59"/>
+        <a:srgbClr val="196B24"/>
       </a:accent3>
       <a:accent4>
-        <a:srgbClr val="8064A2"/>
+        <a:srgbClr val="0F9ED5"/>
       </a:accent4>
       <a:accent5>
-        <a:srgbClr val="4BACC6"/>
+        <a:srgbClr val="A02B93"/>
       </a:accent5>
       <a:accent6>
-        <a:srgbClr val="F79646"/>
+        <a:srgbClr val="4EA72E"/>
       </a:accent6>
       <a:hlink>
-        <a:srgbClr val="0000FF"/>
+        <a:srgbClr val="467886"/>
       </a:hlink>
       <a:folHlink>
-        <a:srgbClr val="800080"/>
+        <a:srgbClr val="96607D"/>
       </a:folHlink>
     </a:clrScheme>
     <a:fontScheme name="Office">
       <a:majorFont>
-        <a:latin typeface="Calibri"/>
+        <a:latin typeface="Aptos Display" panose="02110004020202020204"/>
         <a:ea typeface=""/>
         <a:cs typeface=""/>
-        <a:font script="Jpan" typeface="ＭＳ Ｐゴシック"/>
+        <a:font script="Jpan" typeface="游ゴシック Light"/>
         <a:font script="Hang" typeface="맑은 고딕"/>
-        <a:font script="Hans" typeface="宋体"/>
+        <a:font script="Hans" typeface="等线 Light"/>
         <a:font script="Hant" typeface="新細明體"/>
         <a:font script="Arab" typeface="Times New Roman"/>
         <a:font script="Hebr" typeface="Times New Roman"/>
@@ -11351,14 +11319,31 @@
         <a:font script="Viet" typeface="Times New Roman"/>
         <a:font script="Uigh" typeface="Microsoft Uighur"/>
         <a:font script="Geor" typeface="Sylfaen"/>
+        <a:font script="Armn" typeface="Arial"/>
+        <a:font script="Bugi" typeface="Leelawadee UI"/>
+        <a:font script="Bopo" typeface="Microsoft JhengHei"/>
+        <a:font script="Java" typeface="Javanese Text"/>
+        <a:font script="Lisu" typeface="Segoe UI"/>
+        <a:font script="Mymr" typeface="Myanmar Text"/>
+        <a:font script="Nkoo" typeface="Ebrima"/>
+        <a:font script="Olck" typeface="Nirmala UI"/>
+        <a:font script="Osma" typeface="Ebrima"/>
+        <a:font script="Phag" typeface="Phagspa"/>
+        <a:font script="Syrn" typeface="Estrangelo Edessa"/>
+        <a:font script="Syrj" typeface="Estrangelo Edessa"/>
+        <a:font script="Syre" typeface="Estrangelo Edessa"/>
+        <a:font script="Sora" typeface="Nirmala UI"/>
+        <a:font script="Tale" typeface="Microsoft Tai Le"/>
+        <a:font script="Talu" typeface="Microsoft New Tai Lue"/>
+        <a:font script="Tfng" typeface="Ebrima"/>
       </a:majorFont>
       <a:minorFont>
-        <a:latin typeface="Calibri"/>
+        <a:latin typeface="Aptos" panose="02110004020202020204"/>
         <a:ea typeface=""/>
         <a:cs typeface=""/>
-        <a:font script="Jpan" typeface="ＭＳ Ｐゴシック"/>
+        <a:font script="Jpan" typeface="游ゴシック"/>
         <a:font script="Hang" typeface="맑은 고딕"/>
-        <a:font script="Hans" typeface="宋体"/>
+        <a:font script="Hans" typeface="等线"/>
         <a:font script="Hant" typeface="新細明體"/>
         <a:font script="Arab" typeface="Arial"/>
         <a:font script="Hebr" typeface="Arial"/>
@@ -11386,6 +11371,23 @@
         <a:font script="Viet" typeface="Arial"/>
         <a:font script="Uigh" typeface="Microsoft Uighur"/>
         <a:font script="Geor" typeface="Sylfaen"/>
+        <a:font script="Armn" typeface="Arial"/>
+        <a:font script="Bugi" typeface="Leelawadee UI"/>
+        <a:font script="Bopo" typeface="Microsoft JhengHei"/>
+        <a:font script="Java" typeface="Javanese Text"/>
+        <a:font script="Lisu" typeface="Segoe UI"/>
+        <a:font script="Mymr" typeface="Myanmar Text"/>
+        <a:font script="Nkoo" typeface="Ebrima"/>
+        <a:font script="Olck" typeface="Nirmala UI"/>
+        <a:font script="Osma" typeface="Ebrima"/>
+        <a:font script="Phag" typeface="Phagspa"/>
+        <a:font script="Syrn" typeface="Estrangelo Edessa"/>
+        <a:font script="Syrj" typeface="Estrangelo Edessa"/>
+        <a:font script="Syre" typeface="Estrangelo Edessa"/>
+        <a:font script="Sora" typeface="Nirmala UI"/>
+        <a:font script="Tale" typeface="Microsoft Tai Le"/>
+        <a:font script="Talu" typeface="Microsoft New Tai Lue"/>
+        <a:font script="Tfng" typeface="Ebrima"/>
       </a:minorFont>
     </a:fontScheme>
     <a:fmtScheme name="Office">
@@ -11397,180 +11399,136 @@
           <a:gsLst>
             <a:gs pos="0">
               <a:schemeClr val="phClr">
-                <a:tint val="50000"/>
-                <a:satMod val="300000"/>
+                <a:lumMod val="110000"/>
+                <a:satMod val="105000"/>
+                <a:tint val="67000"/>
               </a:schemeClr>
             </a:gs>
-            <a:gs pos="35000">
+            <a:gs pos="50000">
               <a:schemeClr val="phClr">
-                <a:tint val="37000"/>
-                <a:satMod val="300000"/>
+                <a:lumMod val="105000"/>
+                <a:satMod val="103000"/>
+                <a:tint val="73000"/>
               </a:schemeClr>
             </a:gs>
             <a:gs pos="100000">
               <a:schemeClr val="phClr">
-                <a:tint val="15000"/>
-                <a:satMod val="350000"/>
+                <a:lumMod val="105000"/>
+                <a:satMod val="109000"/>
+                <a:tint val="81000"/>
               </a:schemeClr>
             </a:gs>
           </a:gsLst>
-          <a:lin ang="16200000" scaled="1"/>
+          <a:lin ang="5400000" scaled="0"/>
         </a:gradFill>
         <a:gradFill rotWithShape="1">
           <a:gsLst>
             <a:gs pos="0">
               <a:schemeClr val="phClr">
-                <a:tint val="100000"/>
+                <a:satMod val="103000"/>
+                <a:lumMod val="102000"/>
+                <a:tint val="94000"/>
+              </a:schemeClr>
+            </a:gs>
+            <a:gs pos="50000">
+              <a:schemeClr val="phClr">
+                <a:satMod val="110000"/>
+                <a:lumMod val="100000"/>
                 <a:shade val="100000"/>
-                <a:satMod val="130000"/>
               </a:schemeClr>
             </a:gs>
             <a:gs pos="100000">
               <a:schemeClr val="phClr">
-                <a:tint val="50000"/>
-                <a:shade val="100000"/>
-                <a:satMod val="350000"/>
+                <a:lumMod val="99000"/>
+                <a:satMod val="120000"/>
+                <a:shade val="78000"/>
               </a:schemeClr>
             </a:gs>
           </a:gsLst>
-          <a:lin ang="16200000" scaled="0"/>
+          <a:lin ang="5400000" scaled="0"/>
         </a:gradFill>
       </a:fillStyleLst>
       <a:lnStyleLst>
-        <a:ln w="9525" cap="flat" cmpd="sng" algn="ctr">
+        <a:ln w="12700" cap="flat" cmpd="sng" algn="ctr">
           <a:solidFill>
-            <a:schemeClr val="phClr">
-              <a:shade val="95000"/>
-              <a:satMod val="105000"/>
-            </a:schemeClr>
+            <a:schemeClr val="phClr"/>
           </a:solidFill>
           <a:prstDash val="solid"/>
+          <a:miter lim="800000"/>
+        </a:ln>
+        <a:ln w="19050" cap="flat" cmpd="sng" algn="ctr">
+          <a:solidFill>
+            <a:schemeClr val="phClr"/>
+          </a:solidFill>
+          <a:prstDash val="solid"/>
+          <a:miter lim="800000"/>
         </a:ln>
         <a:ln w="25400" cap="flat" cmpd="sng" algn="ctr">
           <a:solidFill>
             <a:schemeClr val="phClr"/>
           </a:solidFill>
           <a:prstDash val="solid"/>
-        </a:ln>
-        <a:ln w="38100" cap="flat" cmpd="sng" algn="ctr">
-          <a:solidFill>
-            <a:schemeClr val="phClr"/>
-          </a:solidFill>
-          <a:prstDash val="solid"/>
+          <a:miter lim="800000"/>
         </a:ln>
       </a:lnStyleLst>
       <a:effectStyleLst>
         <a:effectStyle>
+          <a:effectLst/>
+        </a:effectStyle>
+        <a:effectStyle>
+          <a:effectLst/>
+        </a:effectStyle>
+        <a:effectStyle>
           <a:effectLst>
-            <a:outerShdw blurRad="40000" dist="20000" dir="5400000" rotWithShape="0">
+            <a:outerShdw blurRad="57150" dist="19050" dir="5400000" algn="ctr" rotWithShape="0">
               <a:srgbClr val="000000">
-                <a:alpha val="38000"/>
+                <a:alpha val="63000"/>
               </a:srgbClr>
             </a:outerShdw>
           </a:effectLst>
-        </a:effectStyle>
-        <a:effectStyle>
-          <a:effectLst>
-            <a:outerShdw blurRad="40000" dist="23000" dir="5400000" rotWithShape="0">
-              <a:srgbClr val="000000">
-                <a:alpha val="35000"/>
-              </a:srgbClr>
-            </a:outerShdw>
-          </a:effectLst>
-        </a:effectStyle>
-        <a:effectStyle>
-          <a:effectLst>
-            <a:outerShdw blurRad="40000" dist="23000" dir="5400000" rotWithShape="0">
-              <a:srgbClr val="000000">
-                <a:alpha val="35000"/>
-              </a:srgbClr>
-            </a:outerShdw>
-          </a:effectLst>
-          <a:scene3d>
-            <a:camera prst="orthographicFront">
-              <a:rot lat="0" lon="0" rev="0"/>
-            </a:camera>
-            <a:lightRig rig="threePt" dir="t">
-              <a:rot lat="0" lon="0" rev="1200000"/>
-            </a:lightRig>
-          </a:scene3d>
-          <a:sp3d>
-            <a:bevelT w="63500" h="25400"/>
-          </a:sp3d>
         </a:effectStyle>
       </a:effectStyleLst>
       <a:bgFillStyleLst>
         <a:solidFill>
           <a:schemeClr val="phClr"/>
         </a:solidFill>
+        <a:solidFill>
+          <a:schemeClr val="phClr">
+            <a:tint val="95000"/>
+            <a:satMod val="170000"/>
+          </a:schemeClr>
+        </a:solidFill>
         <a:gradFill rotWithShape="1">
           <a:gsLst>
             <a:gs pos="0">
               <a:schemeClr val="phClr">
-                <a:tint val="40000"/>
-                <a:satMod val="350000"/>
+                <a:tint val="93000"/>
+                <a:satMod val="150000"/>
+                <a:shade val="98000"/>
+                <a:lumMod val="102000"/>
               </a:schemeClr>
             </a:gs>
-            <a:gs pos="40000">
+            <a:gs pos="50000">
               <a:schemeClr val="phClr">
-                <a:tint val="45000"/>
-                <a:shade val="99000"/>
-                <a:satMod val="350000"/>
+                <a:tint val="98000"/>
+                <a:satMod val="130000"/>
+                <a:shade val="90000"/>
+                <a:lumMod val="103000"/>
               </a:schemeClr>
             </a:gs>
             <a:gs pos="100000">
               <a:schemeClr val="phClr">
-                <a:shade val="20000"/>
-                <a:satMod val="255000"/>
+                <a:shade val="63000"/>
+                <a:satMod val="120000"/>
               </a:schemeClr>
             </a:gs>
           </a:gsLst>
-          <a:path path="circle">
-            <a:fillToRect l="50000" t="-80000" r="50000" b="180000"/>
-          </a:path>
-        </a:gradFill>
-        <a:gradFill rotWithShape="1">
-          <a:gsLst>
-            <a:gs pos="0">
-              <a:schemeClr val="phClr">
-                <a:tint val="80000"/>
-                <a:satMod val="300000"/>
-              </a:schemeClr>
-            </a:gs>
-            <a:gs pos="100000">
-              <a:schemeClr val="phClr">
-                <a:shade val="30000"/>
-                <a:satMod val="200000"/>
-              </a:schemeClr>
-            </a:gs>
-          </a:gsLst>
-          <a:path path="circle">
-            <a:fillToRect l="50000" t="50000" r="50000" b="50000"/>
-          </a:path>
+          <a:lin ang="5400000" scaled="0"/>
         </a:gradFill>
       </a:bgFillStyleLst>
     </a:fmtScheme>
   </a:themeElements>
   <a:objectDefaults>
-    <a:spDef>
-      <a:spPr/>
-      <a:bodyPr/>
-      <a:lstStyle/>
-      <a:style>
-        <a:lnRef idx="1">
-          <a:schemeClr val="accent1"/>
-        </a:lnRef>
-        <a:fillRef idx="3">
-          <a:schemeClr val="accent1"/>
-        </a:fillRef>
-        <a:effectRef idx="2">
-          <a:schemeClr val="accent1"/>
-        </a:effectRef>
-        <a:fontRef idx="minor">
-          <a:schemeClr val="lt1"/>
-        </a:fontRef>
-      </a:style>
-    </a:spDef>
     <a:lnDef>
       <a:spPr/>
       <a:bodyPr/>
@@ -11592,5 +11550,10 @@
     </a:lnDef>
   </a:objectDefaults>
   <a:extraClrSchemeLst/>
+  <a:extLst>
+    <a:ext uri="{05A4C25C-085E-4340-85A3-A5531E510DB2}">
+      <thm15:themeFamily xmlns:thm15="http://schemas.microsoft.com/office/thememl/2012/main" name="Office Theme" id="{2E142A2C-CD16-42D6-873A-C26D2A0506FA}" vid="{1BDDFF52-6CD6-40A5-AB3C-68EB2F1E4D0A}"/>
+    </a:ext>
+  </a:extLst>
 </a:theme>
 </file>
</xml_diff>